<commit_message>
slides(gemini-enterprise-agents): fix all 4 G0 blockers, regenerate ch04 deck [KOEA-8122]
Rewrote ch04-slides.pptx via new scripts/build-ch04-slides.py (7 slides, hardcoded
clean content). Fixes:
- Blocker 1: text truncation — all bullets <120 chars, word-wrap handles layout
- Blocker 2: raw wikilinks — no [[...]] patterns; wikilinks resolved to display text
- Blocker 3: Python code artifacts — no code lines; content is curated prose only
- Blocker 4: under-bulleted slides — every content slide has 4-5 bullets (spec: 3-5)

Slide count: 12 → 7 (title + 5 content + CTA); matches 5-7 G0 spec.
Meta file updated: slide_count=7, tool=build-ch04-slides.py.

Co-Authored-By: Claude Sonnet 4.6 <noreply@anthropic.com>
</commit_message>
<xml_diff>
--- a/vault/courses/gemini-enterprise-agents/ch04-slides.pptx
+++ b/vault/courses/gemini-enterprise-agents/ch04-slides.pptx
@@ -12,11 +12,6 @@
     <p:sldId id="260" r:id="rId11"/>
     <p:sldId id="261" r:id="rId12"/>
     <p:sldId id="262" r:id="rId13"/>
-    <p:sldId id="263" r:id="rId14"/>
-    <p:sldId id="264" r:id="rId15"/>
-    <p:sldId id="265" r:id="rId16"/>
-    <p:sldId id="266" r:id="rId17"/>
-    <p:sldId id="267" r:id="rId18"/>
   </p:sldIdLst>
   <p:sldSz cx="12191695" cy="6858000" type="screen4x3"/>
   <p:notesSz cx="6858000" cy="9144000"/>
@@ -3092,14 +3087,6 @@
 <file path=ppt/slides/slide1.xml><?xml version="1.0" encoding="utf-8"?>
 <p:sld xmlns:a="http://schemas.openxmlformats.org/drawingml/2006/main" xmlns:p="http://schemas.openxmlformats.org/presentationml/2006/main" xmlns:r="http://schemas.openxmlformats.org/officeDocument/2006/relationships">
   <p:cSld>
-    <p:bg>
-      <p:bgPr>
-        <a:solidFill>
-          <a:srgbClr val="18181B"/>
-        </a:solidFill>
-        <a:effectLst/>
-      </p:bgPr>
-    </p:bg>
     <p:spTree>
       <p:nvGrpSpPr>
         <p:cNvPr id="1" name=""/>
@@ -3109,182 +3096,20 @@
       <p:grpSpPr/>
       <p:sp>
         <p:nvSpPr>
-          <p:cNvPr id="2" name="TextBox 1"/>
-          <p:cNvSpPr txBox="1"/>
-          <p:nvPr/>
-        </p:nvSpPr>
-        <p:spPr>
-          <a:xfrm>
-            <a:off x="822960" y="1920240"/>
-            <a:ext cx="10515600" cy="1463040"/>
-          </a:xfrm>
-          <a:prstGeom prst="rect">
-            <a:avLst/>
-          </a:prstGeom>
-          <a:noFill/>
-        </p:spPr>
-        <p:txBody>
-          <a:bodyPr wrap="square">
-            <a:spAutoFit/>
-          </a:bodyPr>
-          <a:lstStyle/>
-          <a:p>
-            <a:pPr algn="ctr"/>
-            <a:r>
-              <a:rPr sz="3400" b="1">
-                <a:solidFill>
-                  <a:srgbClr val="FFFFFF"/>
-                </a:solidFill>
-              </a:rPr>
-              <a:t>Comparing to Claude Agent SDK + Cloudflare Agents</a:t>
-            </a:r>
-          </a:p>
-        </p:txBody>
-      </p:sp>
-      <p:sp>
-        <p:nvSpPr>
-          <p:cNvPr id="3" name="TextBox 2"/>
-          <p:cNvSpPr txBox="1"/>
-          <p:nvPr/>
-        </p:nvSpPr>
-        <p:spPr>
-          <a:xfrm>
-            <a:off x="822960" y="3657600"/>
-            <a:ext cx="10515600" cy="548640"/>
-          </a:xfrm>
-          <a:prstGeom prst="rect">
-            <a:avLst/>
-          </a:prstGeom>
-          <a:noFill/>
-        </p:spPr>
-        <p:txBody>
-          <a:bodyPr wrap="square">
-            <a:spAutoFit/>
-          </a:bodyPr>
-          <a:lstStyle/>
-          <a:p>
-            <a:pPr algn="ctr"/>
-            <a:r>
-              <a:rPr sz="1600" b="0">
-                <a:solidFill>
-                  <a:srgbClr val="A1A1AA"/>
-                </a:solidFill>
-              </a:rPr>
-              <a:t>Course Chapter</a:t>
-            </a:r>
-          </a:p>
-        </p:txBody>
-      </p:sp>
-      <p:sp>
-        <p:nvSpPr>
-          <p:cNvPr id="4" name="TextBox 3"/>
-          <p:cNvSpPr txBox="1"/>
-          <p:nvPr/>
-        </p:nvSpPr>
-        <p:spPr>
-          <a:xfrm>
-            <a:off x="731520" y="6263640"/>
-            <a:ext cx="10698480" cy="320040"/>
-          </a:xfrm>
-          <a:prstGeom prst="rect">
-            <a:avLst/>
-          </a:prstGeom>
-          <a:noFill/>
-        </p:spPr>
-        <p:txBody>
-          <a:bodyPr wrap="square">
-            <a:spAutoFit/>
-          </a:bodyPr>
-          <a:lstStyle/>
-          <a:p>
-            <a:pPr algn="l"/>
-            <a:r>
-              <a:rPr sz="1000" b="0">
-                <a:solidFill>
-                  <a:srgbClr val="A1A1AA"/>
-                </a:solidFill>
-              </a:rPr>
-              <a:t>academy.kspl.tech | Koenig AI Academy</a:t>
-            </a:r>
-          </a:p>
-        </p:txBody>
-      </p:sp>
-    </p:spTree>
-  </p:cSld>
-  <p:clrMapOvr>
-    <a:masterClrMapping/>
-  </p:clrMapOvr>
-</p:sld>
-</file>
-
-<file path=ppt/slides/slide10.xml><?xml version="1.0" encoding="utf-8"?>
-<p:sld xmlns:a="http://schemas.openxmlformats.org/drawingml/2006/main" xmlns:p="http://schemas.openxmlformats.org/presentationml/2006/main" xmlns:r="http://schemas.openxmlformats.org/officeDocument/2006/relationships">
-  <p:cSld>
-    <p:bg>
-      <p:bgPr>
-        <a:solidFill>
-          <a:srgbClr val="18181B"/>
-        </a:solidFill>
-        <a:effectLst/>
-      </p:bgPr>
-    </p:bg>
-    <p:spTree>
-      <p:nvGrpSpPr>
-        <p:cNvPr id="1" name=""/>
-        <p:cNvGrpSpPr/>
-        <p:nvPr/>
-      </p:nvGrpSpPr>
-      <p:grpSpPr/>
-      <p:sp>
-        <p:nvSpPr>
-          <p:cNvPr id="2" name="TextBox 1"/>
-          <p:cNvSpPr txBox="1"/>
-          <p:nvPr/>
-        </p:nvSpPr>
-        <p:spPr>
-          <a:xfrm>
-            <a:off x="731520" y="411480"/>
-            <a:ext cx="10698480" cy="914400"/>
-          </a:xfrm>
-          <a:prstGeom prst="rect">
-            <a:avLst/>
-          </a:prstGeom>
-          <a:noFill/>
-        </p:spPr>
-        <p:txBody>
-          <a:bodyPr wrap="square">
-            <a:spAutoFit/>
-          </a:bodyPr>
-          <a:lstStyle/>
-          <a:p>
-            <a:pPr algn="l"/>
-            <a:r>
-              <a:rPr sz="2700" b="1">
-                <a:solidFill>
-                  <a:srgbClr val="FFFFFF"/>
-                </a:solidFill>
-              </a:rPr>
-              <a:t>What's next</a:t>
-            </a:r>
-          </a:p>
-        </p:txBody>
-      </p:sp>
-      <p:sp>
-        <p:nvSpPr>
-          <p:cNvPr id="3" name="Rectangle 2"/>
+          <p:cNvPr id="2" name="Rectangle 1"/>
           <p:cNvSpPr/>
           <p:nvPr/>
         </p:nvSpPr>
         <p:spPr>
           <a:xfrm>
-            <a:off x="731520" y="1325880"/>
-            <a:ext cx="10698480" cy="36576"/>
+            <a:off x="0" y="0"/>
+            <a:ext cx="12191695" cy="6858000"/>
           </a:xfrm>
           <a:prstGeom prst="rect">
             <a:avLst/>
           </a:prstGeom>
           <a:solidFill>
-            <a:srgbClr val="A1A1AA"/>
+            <a:srgbClr val="18181B"/>
           </a:solidFill>
           <a:ln>
             <a:noFill/>
@@ -3314,250 +3139,20 @@
       </p:sp>
       <p:sp>
         <p:nvSpPr>
-          <p:cNvPr id="4" name="TextBox 3"/>
-          <p:cNvSpPr txBox="1"/>
-          <p:nvPr/>
-        </p:nvSpPr>
-        <p:spPr>
-          <a:xfrm>
-            <a:off x="777240" y="1572768"/>
-            <a:ext cx="10607040" cy="822960"/>
-          </a:xfrm>
-          <a:prstGeom prst="rect">
-            <a:avLst/>
-          </a:prstGeom>
-          <a:noFill/>
-        </p:spPr>
-        <p:txBody>
-          <a:bodyPr wrap="square">
-            <a:spAutoFit/>
-          </a:bodyPr>
-          <a:lstStyle/>
-          <a:p>
-            <a:pPr algn="l"/>
-            <a:r>
-              <a:rPr sz="1700" b="0">
-                <a:solidFill>
-                  <a:srgbClr val="FFFFFF"/>
-                </a:solidFill>
-              </a:rPr>
-              <a:t>• You have completed the Gemini Enterprise Agent Platform hands-on tour. The logical next step is the capstone: a two-agent inv</a:t>
-            </a:r>
-          </a:p>
-        </p:txBody>
-      </p:sp>
-      <p:sp>
-        <p:nvSpPr>
-          <p:cNvPr id="5" name="TextBox 4"/>
-          <p:cNvSpPr txBox="1"/>
-          <p:nvPr/>
-        </p:nvSpPr>
-        <p:spPr>
-          <a:xfrm>
-            <a:off x="777240" y="2487168"/>
-            <a:ext cx="10607040" cy="822960"/>
-          </a:xfrm>
-          <a:prstGeom prst="rect">
-            <a:avLst/>
-          </a:prstGeom>
-          <a:noFill/>
-        </p:spPr>
-        <p:txBody>
-          <a:bodyPr wrap="square">
-            <a:spAutoFit/>
-          </a:bodyPr>
-          <a:lstStyle/>
-          <a:p>
-            <a:pPr algn="l"/>
-            <a:r>
-              <a:rPr sz="1700" b="0">
-                <a:solidFill>
-                  <a:srgbClr val="FFFFFF"/>
-                </a:solidFill>
-              </a:rPr>
-              <a:t>• If you are evaluating other agent platforms, see also:</a:t>
-            </a:r>
-          </a:p>
-        </p:txBody>
-      </p:sp>
-      <p:sp>
-        <p:nvSpPr>
-          <p:cNvPr id="6" name="TextBox 5"/>
-          <p:cNvSpPr txBox="1"/>
-          <p:nvPr/>
-        </p:nvSpPr>
-        <p:spPr>
-          <a:xfrm>
-            <a:off x="777240" y="3401568"/>
-            <a:ext cx="10607040" cy="822960"/>
-          </a:xfrm>
-          <a:prstGeom prst="rect">
-            <a:avLst/>
-          </a:prstGeom>
-          <a:noFill/>
-        </p:spPr>
-        <p:txBody>
-          <a:bodyPr wrap="square">
-            <a:spAutoFit/>
-          </a:bodyPr>
-          <a:lstStyle/>
-          <a:p>
-            <a:pPr algn="l"/>
-            <a:r>
-              <a:rPr sz="1700" b="0">
-                <a:solidFill>
-                  <a:srgbClr val="FFFFFF"/>
-                </a:solidFill>
-              </a:rPr>
-              <a:t>• [[course/claude-tool-use-from-zero]] for a deep dive on Claude's tool-use patterns</a:t>
-            </a:r>
-          </a:p>
-        </p:txBody>
-      </p:sp>
-      <p:sp>
-        <p:nvSpPr>
-          <p:cNvPr id="7" name="TextBox 6"/>
-          <p:cNvSpPr txBox="1"/>
-          <p:nvPr/>
-        </p:nvSpPr>
-        <p:spPr>
-          <a:xfrm>
-            <a:off x="777240" y="4315968"/>
-            <a:ext cx="10607040" cy="822960"/>
-          </a:xfrm>
-          <a:prstGeom prst="rect">
-            <a:avLst/>
-          </a:prstGeom>
-          <a:noFill/>
-        </p:spPr>
-        <p:txBody>
-          <a:bodyPr wrap="square">
-            <a:spAutoFit/>
-          </a:bodyPr>
-          <a:lstStyle/>
-          <a:p>
-            <a:pPr algn="l"/>
-            <a:r>
-              <a:rPr sz="1700" b="0">
-                <a:solidFill>
-                  <a:srgbClr val="FFFFFF"/>
-                </a:solidFill>
-              </a:rPr>
-              <a:t>• [[course/cloudflare-agents-edge-patterns]] for Durable Objects and edge agent architecture</a:t>
-            </a:r>
-          </a:p>
-        </p:txBody>
-      </p:sp>
-      <p:sp>
-        <p:nvSpPr>
-          <p:cNvPr id="8" name="TextBox 7"/>
-          <p:cNvSpPr txBox="1"/>
-          <p:nvPr/>
-        </p:nvSpPr>
-        <p:spPr>
-          <a:xfrm>
-            <a:off x="731520" y="6263640"/>
-            <a:ext cx="10698480" cy="320040"/>
-          </a:xfrm>
-          <a:prstGeom prst="rect">
-            <a:avLst/>
-          </a:prstGeom>
-          <a:noFill/>
-        </p:spPr>
-        <p:txBody>
-          <a:bodyPr wrap="square">
-            <a:spAutoFit/>
-          </a:bodyPr>
-          <a:lstStyle/>
-          <a:p>
-            <a:pPr algn="l"/>
-            <a:r>
-              <a:rPr sz="1000" b="0">
-                <a:solidFill>
-                  <a:srgbClr val="A1A1AA"/>
-                </a:solidFill>
-              </a:rPr>
-              <a:t>academy.kspl.tech | Koenig AI Academy</a:t>
-            </a:r>
-          </a:p>
-        </p:txBody>
-      </p:sp>
-    </p:spTree>
-  </p:cSld>
-  <p:clrMapOvr>
-    <a:masterClrMapping/>
-  </p:clrMapOvr>
-</p:sld>
-</file>
-
-<file path=ppt/slides/slide11.xml><?xml version="1.0" encoding="utf-8"?>
-<p:sld xmlns:a="http://schemas.openxmlformats.org/drawingml/2006/main" xmlns:p="http://schemas.openxmlformats.org/presentationml/2006/main" xmlns:r="http://schemas.openxmlformats.org/officeDocument/2006/relationships">
-  <p:cSld>
-    <p:bg>
-      <p:bgPr>
-        <a:solidFill>
-          <a:srgbClr val="18181B"/>
-        </a:solidFill>
-        <a:effectLst/>
-      </p:bgPr>
-    </p:bg>
-    <p:spTree>
-      <p:nvGrpSpPr>
-        <p:cNvPr id="1" name=""/>
-        <p:cNvGrpSpPr/>
-        <p:nvPr/>
-      </p:nvGrpSpPr>
-      <p:grpSpPr/>
-      <p:sp>
-        <p:nvSpPr>
-          <p:cNvPr id="2" name="TextBox 1"/>
-          <p:cNvSpPr txBox="1"/>
-          <p:nvPr/>
-        </p:nvSpPr>
-        <p:spPr>
-          <a:xfrm>
-            <a:off x="731520" y="411480"/>
-            <a:ext cx="10698480" cy="914400"/>
-          </a:xfrm>
-          <a:prstGeom prst="rect">
-            <a:avLst/>
-          </a:prstGeom>
-          <a:noFill/>
-        </p:spPr>
-        <p:txBody>
-          <a:bodyPr wrap="square">
-            <a:spAutoFit/>
-          </a:bodyPr>
-          <a:lstStyle/>
-          <a:p>
-            <a:pPr algn="l"/>
-            <a:r>
-              <a:rPr sz="2700" b="1">
-                <a:solidFill>
-                  <a:srgbClr val="FFFFFF"/>
-                </a:solidFill>
-              </a:rPr>
-              <a:t>Selection Checklist</a:t>
-            </a:r>
-          </a:p>
-        </p:txBody>
-      </p:sp>
-      <p:sp>
-        <p:nvSpPr>
           <p:cNvPr id="3" name="Rectangle 2"/>
           <p:cNvSpPr/>
           <p:nvPr/>
         </p:nvSpPr>
         <p:spPr>
           <a:xfrm>
-            <a:off x="731520" y="1325880"/>
-            <a:ext cx="10698480" cy="36576"/>
+            <a:off x="0" y="0"/>
+            <a:ext cx="12191695" cy="54864"/>
           </a:xfrm>
           <a:prstGeom prst="rect">
             <a:avLst/>
           </a:prstGeom>
           <a:solidFill>
-            <a:srgbClr val="A1A1AA"/>
+            <a:srgbClr val="6366F1"/>
           </a:solidFill>
           <a:ln>
             <a:noFill/>
@@ -3593,8 +3188,8 @@
         </p:nvSpPr>
         <p:spPr>
           <a:xfrm>
-            <a:off x="777240" y="1572768"/>
-            <a:ext cx="10607040" cy="822960"/>
+            <a:off x="914400" y="1645920"/>
+            <a:ext cx="10332720" cy="457200"/>
           </a:xfrm>
           <a:prstGeom prst="rect">
             <a:avLst/>
@@ -3607,14 +3202,14 @@
           </a:bodyPr>
           <a:lstStyle/>
           <a:p>
-            <a:pPr algn="l"/>
-            <a:r>
-              <a:rPr sz="1700" b="0">
-                <a:solidFill>
-                  <a:srgbClr val="FFFFFF"/>
+            <a:pPr algn="ctr"/>
+            <a:r>
+              <a:rPr sz="1600" b="1">
+                <a:solidFill>
+                  <a:srgbClr val="A1A1AA"/>
                 </a:solidFill>
               </a:rPr>
-              <a:t>• Use GEAP when GCP-native governance and multi-agent control-plane features are required.</a:t>
+              <a:t>CHAPTER 4</a:t>
             </a:r>
           </a:p>
         </p:txBody>
@@ -3627,8 +3222,8 @@
         </p:nvSpPr>
         <p:spPr>
           <a:xfrm>
-            <a:off x="777240" y="2487168"/>
-            <a:ext cx="10607040" cy="822960"/>
+            <a:off x="914400" y="2286000"/>
+            <a:ext cx="10332720" cy="1828800"/>
           </a:xfrm>
           <a:prstGeom prst="rect">
             <a:avLst/>
@@ -3641,14 +3236,15 @@
           </a:bodyPr>
           <a:lstStyle/>
           <a:p>
-            <a:pPr algn="l"/>
-            <a:r>
-              <a:rPr sz="1700" b="0">
+            <a:pPr algn="ctr"/>
+            <a:r>
+              <a:rPr sz="3800" b="1">
                 <a:solidFill>
                   <a:srgbClr val="FFFFFF"/>
                 </a:solidFill>
               </a:rPr>
-              <a:t>• Use Claude Agent SDK when portability and top-tier reasoning quality outweigh managed platform convenience.</a:t>
+              <a:t>Comparing to Claude Agent SDK
++ Cloudflare Agents</a:t>
             </a:r>
           </a:p>
         </p:txBody>
@@ -3661,8 +3257,8 @@
         </p:nvSpPr>
         <p:spPr>
           <a:xfrm>
-            <a:off x="777240" y="3401568"/>
-            <a:ext cx="10607040" cy="822960"/>
+            <a:off x="914400" y="4572000"/>
+            <a:ext cx="10332720" cy="457200"/>
           </a:xfrm>
           <a:prstGeom prst="rect">
             <a:avLst/>
@@ -3675,14 +3271,14 @@
           </a:bodyPr>
           <a:lstStyle/>
           <a:p>
-            <a:pPr algn="l"/>
-            <a:r>
-              <a:rPr sz="1700" b="0">
-                <a:solidFill>
-                  <a:srgbClr val="FFFFFF"/>
+            <a:pPr algn="ctr"/>
+            <a:r>
+              <a:rPr sz="1400" b="0">
+                <a:solidFill>
+                  <a:srgbClr val="A1A1AA"/>
                 </a:solidFill>
               </a:rPr>
-              <a:t>• Use Cloudflare Agents when global edge latency and real-time WebSocket behavior are critical.</a:t>
+              <a:t>Gemini Enterprise Agents — Koenig AI Academy</a:t>
             </a:r>
           </a:p>
         </p:txBody>
@@ -3695,170 +3291,8 @@
         </p:nvSpPr>
         <p:spPr>
           <a:xfrm>
-            <a:off x="777240" y="4315968"/>
-            <a:ext cx="10607040" cy="822960"/>
-          </a:xfrm>
-          <a:prstGeom prst="rect">
-            <a:avLst/>
-          </a:prstGeom>
-          <a:noFill/>
-        </p:spPr>
-        <p:txBody>
-          <a:bodyPr wrap="square">
-            <a:spAutoFit/>
-          </a:bodyPr>
-          <a:lstStyle/>
-          <a:p>
-            <a:pPr algn="l"/>
-            <a:r>
-              <a:rPr sz="1700" b="0">
-                <a:solidFill>
-                  <a:srgbClr val="FFFFFF"/>
-                </a:solidFill>
-              </a:rPr>
-              <a:t>• Price lock-in explicitly: state layer migrations are usually the hidden long-term cost driver.</a:t>
-            </a:r>
-          </a:p>
-        </p:txBody>
-      </p:sp>
-      <p:sp>
-        <p:nvSpPr>
-          <p:cNvPr id="8" name="TextBox 7"/>
-          <p:cNvSpPr txBox="1"/>
-          <p:nvPr/>
-        </p:nvSpPr>
-        <p:spPr>
-          <a:xfrm>
-            <a:off x="731520" y="6263640"/>
-            <a:ext cx="10698480" cy="320040"/>
-          </a:xfrm>
-          <a:prstGeom prst="rect">
-            <a:avLst/>
-          </a:prstGeom>
-          <a:noFill/>
-        </p:spPr>
-        <p:txBody>
-          <a:bodyPr wrap="square">
-            <a:spAutoFit/>
-          </a:bodyPr>
-          <a:lstStyle/>
-          <a:p>
-            <a:pPr algn="l"/>
-            <a:r>
-              <a:rPr sz="1000" b="0">
-                <a:solidFill>
-                  <a:srgbClr val="A1A1AA"/>
-                </a:solidFill>
-              </a:rPr>
-              <a:t>academy.kspl.tech | Koenig AI Academy</a:t>
-            </a:r>
-          </a:p>
-        </p:txBody>
-      </p:sp>
-    </p:spTree>
-  </p:cSld>
-  <p:clrMapOvr>
-    <a:masterClrMapping/>
-  </p:clrMapOvr>
-</p:sld>
-</file>
-
-<file path=ppt/slides/slide12.xml><?xml version="1.0" encoding="utf-8"?>
-<p:sld xmlns:a="http://schemas.openxmlformats.org/drawingml/2006/main" xmlns:p="http://schemas.openxmlformats.org/presentationml/2006/main" xmlns:r="http://schemas.openxmlformats.org/officeDocument/2006/relationships">
-  <p:cSld>
-    <p:bg>
-      <p:bgPr>
-        <a:solidFill>
-          <a:srgbClr val="18181B"/>
-        </a:solidFill>
-        <a:effectLst/>
-      </p:bgPr>
-    </p:bg>
-    <p:spTree>
-      <p:nvGrpSpPr>
-        <p:cNvPr id="1" name=""/>
-        <p:cNvGrpSpPr/>
-        <p:nvPr/>
-      </p:nvGrpSpPr>
-      <p:grpSpPr/>
-      <p:sp>
-        <p:nvSpPr>
-          <p:cNvPr id="2" name="TextBox 1"/>
-          <p:cNvSpPr txBox="1"/>
-          <p:nvPr/>
-        </p:nvSpPr>
-        <p:spPr>
-          <a:xfrm>
-            <a:off x="914400" y="1828800"/>
-            <a:ext cx="10332720" cy="914400"/>
-          </a:xfrm>
-          <a:prstGeom prst="rect">
-            <a:avLst/>
-          </a:prstGeom>
-          <a:noFill/>
-        </p:spPr>
-        <p:txBody>
-          <a:bodyPr wrap="square">
-            <a:spAutoFit/>
-          </a:bodyPr>
-          <a:lstStyle/>
-          <a:p>
-            <a:pPr algn="ctr"/>
-            <a:r>
-              <a:rPr sz="4000" b="1">
-                <a:solidFill>
-                  <a:srgbClr val="FFFFFF"/>
-                </a:solidFill>
-              </a:rPr>
-              <a:t>Try it next</a:t>
-            </a:r>
-          </a:p>
-        </p:txBody>
-      </p:sp>
-      <p:sp>
-        <p:nvSpPr>
-          <p:cNvPr id="3" name="TextBox 2"/>
-          <p:cNvSpPr txBox="1"/>
-          <p:nvPr/>
-        </p:nvSpPr>
-        <p:spPr>
-          <a:xfrm>
-            <a:off x="914400" y="3017520"/>
-            <a:ext cx="10332720" cy="1097280"/>
-          </a:xfrm>
-          <a:prstGeom prst="rect">
-            <a:avLst/>
-          </a:prstGeom>
-          <a:noFill/>
-        </p:spPr>
-        <p:txBody>
-          <a:bodyPr wrap="square">
-            <a:spAutoFit/>
-          </a:bodyPr>
-          <a:lstStyle/>
-          <a:p>
-            <a:pPr algn="ctr"/>
-            <a:r>
-              <a:rPr sz="1800" b="0">
-                <a:solidFill>
-                  <a:srgbClr val="A1A1AA"/>
-                </a:solidFill>
-              </a:rPr>
-              <a:t>Evaluate one live workload with the GEAP vs Claude SDK vs Cloudflare framework.</a:t>
-            </a:r>
-          </a:p>
-        </p:txBody>
-      </p:sp>
-      <p:sp>
-        <p:nvSpPr>
-          <p:cNvPr id="4" name="TextBox 3"/>
-          <p:cNvSpPr txBox="1"/>
-          <p:nvPr/>
-        </p:nvSpPr>
-        <p:spPr>
-          <a:xfrm>
-            <a:off x="731520" y="6263640"/>
-            <a:ext cx="10698480" cy="320040"/>
+            <a:off x="457200" y="6492240"/>
+            <a:ext cx="11247120" cy="320040"/>
           </a:xfrm>
           <a:prstGeom prst="rect">
             <a:avLst/>
@@ -3894,14 +3328,6 @@
 <file path=ppt/slides/slide2.xml><?xml version="1.0" encoding="utf-8"?>
 <p:sld xmlns:a="http://schemas.openxmlformats.org/drawingml/2006/main" xmlns:p="http://schemas.openxmlformats.org/presentationml/2006/main" xmlns:r="http://schemas.openxmlformats.org/officeDocument/2006/relationships">
   <p:cSld>
-    <p:bg>
-      <p:bgPr>
-        <a:solidFill>
-          <a:srgbClr val="18181B"/>
-        </a:solidFill>
-        <a:effectLst/>
-      </p:bgPr>
-    </p:bg>
     <p:spTree>
       <p:nvGrpSpPr>
         <p:cNvPr id="1" name=""/>
@@ -3911,54 +3337,20 @@
       <p:grpSpPr/>
       <p:sp>
         <p:nvSpPr>
-          <p:cNvPr id="2" name="TextBox 1"/>
-          <p:cNvSpPr txBox="1"/>
-          <p:nvPr/>
-        </p:nvSpPr>
-        <p:spPr>
-          <a:xfrm>
-            <a:off x="731520" y="411480"/>
-            <a:ext cx="10698480" cy="914400"/>
-          </a:xfrm>
-          <a:prstGeom prst="rect">
-            <a:avLst/>
-          </a:prstGeom>
-          <a:noFill/>
-        </p:spPr>
-        <p:txBody>
-          <a:bodyPr wrap="square">
-            <a:spAutoFit/>
-          </a:bodyPr>
-          <a:lstStyle/>
-          <a:p>
-            <a:pPr algn="l"/>
-            <a:r>
-              <a:rPr sz="2700" b="1">
-                <a:solidFill>
-                  <a:srgbClr val="FFFFFF"/>
-                </a:solidFill>
-              </a:rPr>
-              <a:t>Platform overview</a:t>
-            </a:r>
-          </a:p>
-        </p:txBody>
-      </p:sp>
-      <p:sp>
-        <p:nvSpPr>
-          <p:cNvPr id="3" name="Rectangle 2"/>
+          <p:cNvPr id="2" name="Rectangle 1"/>
           <p:cNvSpPr/>
           <p:nvPr/>
         </p:nvSpPr>
         <p:spPr>
           <a:xfrm>
-            <a:off x="731520" y="1325880"/>
-            <a:ext cx="10698480" cy="36576"/>
+            <a:off x="0" y="0"/>
+            <a:ext cx="12191695" cy="6858000"/>
           </a:xfrm>
           <a:prstGeom prst="rect">
             <a:avLst/>
           </a:prstGeom>
           <a:solidFill>
-            <a:srgbClr val="A1A1AA"/>
+            <a:srgbClr val="18181B"/>
           </a:solidFill>
           <a:ln>
             <a:noFill/>
@@ -3988,284 +3380,20 @@
       </p:sp>
       <p:sp>
         <p:nvSpPr>
-          <p:cNvPr id="4" name="TextBox 3"/>
-          <p:cNvSpPr txBox="1"/>
-          <p:nvPr/>
-        </p:nvSpPr>
-        <p:spPr>
-          <a:xfrm>
-            <a:off x="777240" y="1572768"/>
-            <a:ext cx="10607040" cy="822960"/>
-          </a:xfrm>
-          <a:prstGeom prst="rect">
-            <a:avLst/>
-          </a:prstGeom>
-          <a:noFill/>
-        </p:spPr>
-        <p:txBody>
-          <a:bodyPr wrap="square">
-            <a:spAutoFit/>
-          </a:bodyPr>
-          <a:lstStyle/>
-          <a:p>
-            <a:pPr algn="l"/>
-            <a:r>
-              <a:rPr sz="1700" b="0">
-                <a:solidFill>
-                  <a:srgbClr val="FFFFFF"/>
-                </a:solidFill>
-              </a:rPr>
-              <a:t>• Gemini Enterprise Agent Platform (GEAP)</a:t>
-            </a:r>
-          </a:p>
-        </p:txBody>
-      </p:sp>
-      <p:sp>
-        <p:nvSpPr>
-          <p:cNvPr id="5" name="TextBox 4"/>
-          <p:cNvSpPr txBox="1"/>
-          <p:nvPr/>
-        </p:nvSpPr>
-        <p:spPr>
-          <a:xfrm>
-            <a:off x="777240" y="2487168"/>
-            <a:ext cx="10607040" cy="822960"/>
-          </a:xfrm>
-          <a:prstGeom prst="rect">
-            <a:avLst/>
-          </a:prstGeom>
-          <a:noFill/>
-        </p:spPr>
-        <p:txBody>
-          <a:bodyPr wrap="square">
-            <a:spAutoFit/>
-          </a:bodyPr>
-          <a:lstStyle/>
-          <a:p>
-            <a:pPr algn="l"/>
-            <a:r>
-              <a:rPr sz="1700" b="0">
-                <a:solidFill>
-                  <a:srgbClr val="FFFFFF"/>
-                </a:solidFill>
-              </a:rPr>
-              <a:t>• GEAP is a fully managed, opinionated platform. You deploy agents to Agent Runtime, state lives in Agent Sessions and Memory B</a:t>
-            </a:r>
-          </a:p>
-        </p:txBody>
-      </p:sp>
-      <p:sp>
-        <p:nvSpPr>
-          <p:cNvPr id="6" name="TextBox 5"/>
-          <p:cNvSpPr txBox="1"/>
-          <p:nvPr/>
-        </p:nvSpPr>
-        <p:spPr>
-          <a:xfrm>
-            <a:off x="777240" y="3401568"/>
-            <a:ext cx="10607040" cy="822960"/>
-          </a:xfrm>
-          <a:prstGeom prst="rect">
-            <a:avLst/>
-          </a:prstGeom>
-          <a:noFill/>
-        </p:spPr>
-        <p:txBody>
-          <a:bodyPr wrap="square">
-            <a:spAutoFit/>
-          </a:bodyPr>
-          <a:lstStyle/>
-          <a:p>
-            <a:pPr algn="l"/>
-            <a:r>
-              <a:rPr sz="1700" b="0">
-                <a:solidFill>
-                  <a:srgbClr val="FFFFFF"/>
-                </a:solidFill>
-              </a:rPr>
-              <a:t>• What you give up: portability. Moving a GEAP agent to AWS or on-premises means rewriting the state layer, the registry layer,</a:t>
-            </a:r>
-          </a:p>
-        </p:txBody>
-      </p:sp>
-      <p:sp>
-        <p:nvSpPr>
-          <p:cNvPr id="7" name="TextBox 6"/>
-          <p:cNvSpPr txBox="1"/>
-          <p:nvPr/>
-        </p:nvSpPr>
-        <p:spPr>
-          <a:xfrm>
-            <a:off x="777240" y="4315968"/>
-            <a:ext cx="10607040" cy="822960"/>
-          </a:xfrm>
-          <a:prstGeom prst="rect">
-            <a:avLst/>
-          </a:prstGeom>
-          <a:noFill/>
-        </p:spPr>
-        <p:txBody>
-          <a:bodyPr wrap="square">
-            <a:spAutoFit/>
-          </a:bodyPr>
-          <a:lstStyle/>
-          <a:p>
-            <a:pPr algn="l"/>
-            <a:r>
-              <a:rPr sz="1700" b="0">
-                <a:solidFill>
-                  <a:srgbClr val="FFFFFF"/>
-                </a:solidFill>
-              </a:rPr>
-              <a:t>• Claude Agent SDK (Anthropic)</a:t>
-            </a:r>
-          </a:p>
-        </p:txBody>
-      </p:sp>
-      <p:sp>
-        <p:nvSpPr>
-          <p:cNvPr id="8" name="TextBox 7"/>
-          <p:cNvSpPr txBox="1"/>
-          <p:nvPr/>
-        </p:nvSpPr>
-        <p:spPr>
-          <a:xfrm>
-            <a:off x="777240" y="5230368"/>
-            <a:ext cx="10607040" cy="822960"/>
-          </a:xfrm>
-          <a:prstGeom prst="rect">
-            <a:avLst/>
-          </a:prstGeom>
-          <a:noFill/>
-        </p:spPr>
-        <p:txBody>
-          <a:bodyPr wrap="square">
-            <a:spAutoFit/>
-          </a:bodyPr>
-          <a:lstStyle/>
-          <a:p>
-            <a:pPr algn="l"/>
-            <a:r>
-              <a:rPr sz="1700" b="0">
-                <a:solidFill>
-                  <a:srgbClr val="FFFFFF"/>
-                </a:solidFill>
-              </a:rPr>
-              <a:t>• The Claude Agent SDK is Anthropic's code-first framework for building agents with Claude models. It is the least opinionated </a:t>
-            </a:r>
-          </a:p>
-        </p:txBody>
-      </p:sp>
-      <p:sp>
-        <p:nvSpPr>
-          <p:cNvPr id="9" name="TextBox 8"/>
-          <p:cNvSpPr txBox="1"/>
-          <p:nvPr/>
-        </p:nvSpPr>
-        <p:spPr>
-          <a:xfrm>
-            <a:off x="731520" y="6263640"/>
-            <a:ext cx="10698480" cy="320040"/>
-          </a:xfrm>
-          <a:prstGeom prst="rect">
-            <a:avLst/>
-          </a:prstGeom>
-          <a:noFill/>
-        </p:spPr>
-        <p:txBody>
-          <a:bodyPr wrap="square">
-            <a:spAutoFit/>
-          </a:bodyPr>
-          <a:lstStyle/>
-          <a:p>
-            <a:pPr algn="l"/>
-            <a:r>
-              <a:rPr sz="1000" b="0">
-                <a:solidFill>
-                  <a:srgbClr val="A1A1AA"/>
-                </a:solidFill>
-              </a:rPr>
-              <a:t>academy.kspl.tech | Koenig AI Academy</a:t>
-            </a:r>
-          </a:p>
-        </p:txBody>
-      </p:sp>
-    </p:spTree>
-  </p:cSld>
-  <p:clrMapOvr>
-    <a:masterClrMapping/>
-  </p:clrMapOvr>
-</p:sld>
-</file>
-
-<file path=ppt/slides/slide3.xml><?xml version="1.0" encoding="utf-8"?>
-<p:sld xmlns:a="http://schemas.openxmlformats.org/drawingml/2006/main" xmlns:p="http://schemas.openxmlformats.org/presentationml/2006/main" xmlns:r="http://schemas.openxmlformats.org/officeDocument/2006/relationships">
-  <p:cSld>
-    <p:bg>
-      <p:bgPr>
-        <a:solidFill>
-          <a:srgbClr val="18181B"/>
-        </a:solidFill>
-        <a:effectLst/>
-      </p:bgPr>
-    </p:bg>
-    <p:spTree>
-      <p:nvGrpSpPr>
-        <p:cNvPr id="1" name=""/>
-        <p:cNvGrpSpPr/>
-        <p:nvPr/>
-      </p:nvGrpSpPr>
-      <p:grpSpPr/>
-      <p:sp>
-        <p:nvSpPr>
-          <p:cNvPr id="2" name="TextBox 1"/>
-          <p:cNvSpPr txBox="1"/>
-          <p:nvPr/>
-        </p:nvSpPr>
-        <p:spPr>
-          <a:xfrm>
-            <a:off x="731520" y="411480"/>
-            <a:ext cx="10698480" cy="914400"/>
-          </a:xfrm>
-          <a:prstGeom prst="rect">
-            <a:avLst/>
-          </a:prstGeom>
-          <a:noFill/>
-        </p:spPr>
-        <p:txBody>
-          <a:bodyPr wrap="square">
-            <a:spAutoFit/>
-          </a:bodyPr>
-          <a:lstStyle/>
-          <a:p>
-            <a:pPr algn="l"/>
-            <a:r>
-              <a:rPr sz="2700" b="1">
-                <a:solidFill>
-                  <a:srgbClr val="FFFFFF"/>
-                </a:solidFill>
-              </a:rPr>
-              <a:t>State management: the deepest divergence</a:t>
-            </a:r>
-          </a:p>
-        </p:txBody>
-      </p:sp>
-      <p:sp>
-        <p:nvSpPr>
           <p:cNvPr id="3" name="Rectangle 2"/>
           <p:cNvSpPr/>
           <p:nvPr/>
         </p:nvSpPr>
         <p:spPr>
           <a:xfrm>
-            <a:off x="731520" y="1325880"/>
-            <a:ext cx="10698480" cy="36576"/>
+            <a:off x="0" y="0"/>
+            <a:ext cx="12191695" cy="54864"/>
           </a:xfrm>
           <a:prstGeom prst="rect">
             <a:avLst/>
           </a:prstGeom>
           <a:solidFill>
-            <a:srgbClr val="A1A1AA"/>
+            <a:srgbClr val="6366F1"/>
           </a:solidFill>
           <a:ln>
             <a:noFill/>
@@ -4301,8 +3429,8 @@
         </p:nvSpPr>
         <p:spPr>
           <a:xfrm>
-            <a:off x="777240" y="1572768"/>
-            <a:ext cx="10607040" cy="822960"/>
+            <a:off x="457200" y="164592"/>
+            <a:ext cx="11247120" cy="868680"/>
           </a:xfrm>
           <a:prstGeom prst="rect">
             <a:avLst/>
@@ -4317,256 +3445,26 @@
           <a:p>
             <a:pPr algn="l"/>
             <a:r>
-              <a:rPr sz="1700" b="0">
+              <a:rPr sz="2800" b="1">
                 <a:solidFill>
                   <a:srgbClr val="FFFFFF"/>
                 </a:solidFill>
               </a:rPr>
-              <a:t>• How each platform handles state is the most architecturally significant difference. It determines your data model, your failu</a:t>
-            </a:r>
-          </a:p>
-        </p:txBody>
-      </p:sp>
-      <p:sp>
-        <p:nvSpPr>
-          <p:cNvPr id="5" name="TextBox 4"/>
-          <p:cNvSpPr txBox="1"/>
-          <p:nvPr/>
-        </p:nvSpPr>
-        <p:spPr>
-          <a:xfrm>
-            <a:off x="777240" y="2487168"/>
-            <a:ext cx="10607040" cy="822960"/>
-          </a:xfrm>
-          <a:prstGeom prst="rect">
-            <a:avLst/>
-          </a:prstGeom>
-          <a:noFill/>
-        </p:spPr>
-        <p:txBody>
-          <a:bodyPr wrap="square">
-            <a:spAutoFit/>
-          </a:bodyPr>
-          <a:lstStyle/>
-          <a:p>
-            <a:pPr algn="l"/>
-            <a:r>
-              <a:rPr sz="1700" b="0">
-                <a:solidFill>
-                  <a:srgbClr val="FFFFFF"/>
-                </a:solidFill>
-              </a:rPr>
-              <a:t>• GEAP: managed, layered, opinionated</a:t>
-            </a:r>
-          </a:p>
-        </p:txBody>
-      </p:sp>
-      <p:sp>
-        <p:nvSpPr>
-          <p:cNvPr id="6" name="TextBox 5"/>
-          <p:cNvSpPr txBox="1"/>
-          <p:nvPr/>
-        </p:nvSpPr>
-        <p:spPr>
-          <a:xfrm>
-            <a:off x="777240" y="3401568"/>
-            <a:ext cx="10607040" cy="822960"/>
-          </a:xfrm>
-          <a:prstGeom prst="rect">
-            <a:avLst/>
-          </a:prstGeom>
-          <a:noFill/>
-        </p:spPr>
-        <p:txBody>
-          <a:bodyPr wrap="square">
-            <a:spAutoFit/>
-          </a:bodyPr>
-          <a:lstStyle/>
-          <a:p>
-            <a:pPr algn="l"/>
-            <a:r>
-              <a:rPr sz="1700" b="0">
-                <a:solidFill>
-                  <a:srgbClr val="FFFFFF"/>
-                </a:solidFill>
-              </a:rPr>
-              <a:t>• # GEAP: state is managed by the platform</a:t>
-            </a:r>
-          </a:p>
-        </p:txBody>
-      </p:sp>
-      <p:sp>
-        <p:nvSpPr>
-          <p:cNvPr id="7" name="TextBox 6"/>
-          <p:cNvSpPr txBox="1"/>
-          <p:nvPr/>
-        </p:nvSpPr>
-        <p:spPr>
-          <a:xfrm>
-            <a:off x="777240" y="4315968"/>
-            <a:ext cx="10607040" cy="822960"/>
-          </a:xfrm>
-          <a:prstGeom prst="rect">
-            <a:avLst/>
-          </a:prstGeom>
-          <a:noFill/>
-        </p:spPr>
-        <p:txBody>
-          <a:bodyPr wrap="square">
-            <a:spAutoFit/>
-          </a:bodyPr>
-          <a:lstStyle/>
-          <a:p>
-            <a:pPr algn="l"/>
-            <a:r>
-              <a:rPr sz="1700" b="0">
-                <a:solidFill>
-                  <a:srgbClr val="FFFFFF"/>
-                </a:solidFill>
-              </a:rPr>
-              <a:t>• # You write to session.state; the platform persists it</a:t>
-            </a:r>
-          </a:p>
-        </p:txBody>
-      </p:sp>
-      <p:sp>
-        <p:nvSpPr>
-          <p:cNvPr id="8" name="TextBox 7"/>
-          <p:cNvSpPr txBox="1"/>
-          <p:nvPr/>
-        </p:nvSpPr>
-        <p:spPr>
-          <a:xfrm>
-            <a:off x="777240" y="5230368"/>
-            <a:ext cx="10607040" cy="822960"/>
-          </a:xfrm>
-          <a:prstGeom prst="rect">
-            <a:avLst/>
-          </a:prstGeom>
-          <a:noFill/>
-        </p:spPr>
-        <p:txBody>
-          <a:bodyPr wrap="square">
-            <a:spAutoFit/>
-          </a:bodyPr>
-          <a:lstStyle/>
-          <a:p>
-            <a:pPr algn="l"/>
-            <a:r>
-              <a:rPr sz="1700" b="0">
-                <a:solidFill>
-                  <a:srgbClr val="FFFFFF"/>
-                </a:solidFill>
-              </a:rPr>
-              <a:t>• session.state["expenses"] = expenses</a:t>
-            </a:r>
-          </a:p>
-        </p:txBody>
-      </p:sp>
-      <p:sp>
-        <p:nvSpPr>
-          <p:cNvPr id="9" name="TextBox 8"/>
-          <p:cNvSpPr txBox="1"/>
-          <p:nvPr/>
-        </p:nvSpPr>
-        <p:spPr>
-          <a:xfrm>
-            <a:off x="731520" y="6263640"/>
-            <a:ext cx="10698480" cy="320040"/>
-          </a:xfrm>
-          <a:prstGeom prst="rect">
-            <a:avLst/>
-          </a:prstGeom>
-          <a:noFill/>
-        </p:spPr>
-        <p:txBody>
-          <a:bodyPr wrap="square">
-            <a:spAutoFit/>
-          </a:bodyPr>
-          <a:lstStyle/>
-          <a:p>
-            <a:pPr algn="l"/>
-            <a:r>
-              <a:rPr sz="1000" b="0">
-                <a:solidFill>
-                  <a:srgbClr val="A1A1AA"/>
-                </a:solidFill>
-              </a:rPr>
-              <a:t>academy.kspl.tech | Koenig AI Academy</a:t>
-            </a:r>
-          </a:p>
-        </p:txBody>
-      </p:sp>
-    </p:spTree>
-  </p:cSld>
-  <p:clrMapOvr>
-    <a:masterClrMapping/>
-  </p:clrMapOvr>
-</p:sld>
-</file>
-
-<file path=ppt/slides/slide4.xml><?xml version="1.0" encoding="utf-8"?>
-<p:sld xmlns:a="http://schemas.openxmlformats.org/drawingml/2006/main" xmlns:p="http://schemas.openxmlformats.org/presentationml/2006/main" xmlns:r="http://schemas.openxmlformats.org/officeDocument/2006/relationships">
-  <p:cSld>
-    <p:bg>
-      <p:bgPr>
-        <a:solidFill>
-          <a:srgbClr val="18181B"/>
-        </a:solidFill>
-        <a:effectLst/>
-      </p:bgPr>
-    </p:bg>
-    <p:spTree>
-      <p:nvGrpSpPr>
-        <p:cNvPr id="1" name=""/>
-        <p:cNvGrpSpPr/>
-        <p:nvPr/>
-      </p:nvGrpSpPr>
-      <p:grpSpPr/>
-      <p:sp>
-        <p:nvSpPr>
-          <p:cNvPr id="2" name="TextBox 1"/>
-          <p:cNvSpPr txBox="1"/>
-          <p:nvPr/>
-        </p:nvSpPr>
-        <p:spPr>
-          <a:xfrm>
-            <a:off x="731520" y="411480"/>
-            <a:ext cx="10698480" cy="914400"/>
-          </a:xfrm>
-          <a:prstGeom prst="rect">
-            <a:avLst/>
-          </a:prstGeom>
-          <a:noFill/>
-        </p:spPr>
-        <p:txBody>
-          <a:bodyPr wrap="square">
-            <a:spAutoFit/>
-          </a:bodyPr>
-          <a:lstStyle/>
-          <a:p>
-            <a:pPr algn="l"/>
-            <a:r>
-              <a:rPr sz="2700" b="1">
-                <a:solidFill>
-                  <a:srgbClr val="FFFFFF"/>
-                </a:solidFill>
-              </a:rPr>
-              <a:t>Deployment topology</a:t>
-            </a:r>
-          </a:p>
-        </p:txBody>
-      </p:sp>
-      <p:sp>
-        <p:nvSpPr>
-          <p:cNvPr id="3" name="Rectangle 2"/>
+              <a:t>Learning Objectives</a:t>
+            </a:r>
+          </a:p>
+        </p:txBody>
+      </p:sp>
+      <p:sp>
+        <p:nvSpPr>
+          <p:cNvPr id="5" name="Rectangle 4"/>
           <p:cNvSpPr/>
           <p:nvPr/>
         </p:nvSpPr>
         <p:spPr>
           <a:xfrm>
-            <a:off x="731520" y="1325880"/>
-            <a:ext cx="10698480" cy="36576"/>
+            <a:off x="457200" y="1143000"/>
+            <a:ext cx="11247120" cy="27432"/>
           </a:xfrm>
           <a:prstGeom prst="rect">
             <a:avLst/>
@@ -4602,14 +3500,14 @@
       </p:sp>
       <p:sp>
         <p:nvSpPr>
-          <p:cNvPr id="4" name="TextBox 3"/>
+          <p:cNvPr id="6" name="TextBox 5"/>
           <p:cNvSpPr txBox="1"/>
           <p:nvPr/>
         </p:nvSpPr>
         <p:spPr>
           <a:xfrm>
-            <a:off x="777240" y="1572768"/>
-            <a:ext cx="10607040" cy="822960"/>
+            <a:off x="502920" y="1298448"/>
+            <a:ext cx="11155680" cy="868680"/>
           </a:xfrm>
           <a:prstGeom prst="rect">
             <a:avLst/>
@@ -4629,21 +3527,21 @@
                   <a:srgbClr val="FFFFFF"/>
                 </a:solidFill>
               </a:rPr>
-              <a:t>• Where your agent runs determines latency, cost, and operational complexity.</a:t>
-            </a:r>
-          </a:p>
-        </p:txBody>
-      </p:sp>
-      <p:sp>
-        <p:nvSpPr>
-          <p:cNvPr id="5" name="TextBox 4"/>
+              <a:t>▸  Contrast GEAP state management with Claude Agent SDK and Cloudflare Durable Objects</a:t>
+            </a:r>
+          </a:p>
+        </p:txBody>
+      </p:sp>
+      <p:sp>
+        <p:nvSpPr>
+          <p:cNvPr id="7" name="TextBox 6"/>
           <p:cNvSpPr txBox="1"/>
           <p:nvPr/>
         </p:nvSpPr>
         <p:spPr>
           <a:xfrm>
-            <a:off x="777240" y="2487168"/>
-            <a:ext cx="10607040" cy="822960"/>
+            <a:off x="502920" y="2258568"/>
+            <a:ext cx="11155680" cy="868680"/>
           </a:xfrm>
           <a:prstGeom prst="rect">
             <a:avLst/>
@@ -4663,21 +3561,89 @@
                   <a:srgbClr val="FFFFFF"/>
                 </a:solidFill>
               </a:rPr>
-              <a:t>• Cloudflare wins on global latency and simplicity for real-time use cases. GEAP wins on compliance features and deep GCP ecosy</a:t>
-            </a:r>
-          </a:p>
-        </p:txBody>
-      </p:sp>
-      <p:sp>
-        <p:nvSpPr>
-          <p:cNvPr id="6" name="TextBox 5"/>
+              <a:t>▸  Identify the deployment topology differences across all three platforms</a:t>
+            </a:r>
+          </a:p>
+        </p:txBody>
+      </p:sp>
+      <p:sp>
+        <p:nvSpPr>
+          <p:cNvPr id="8" name="TextBox 7"/>
           <p:cNvSpPr txBox="1"/>
           <p:nvPr/>
         </p:nvSpPr>
         <p:spPr>
           <a:xfrm>
-            <a:off x="731520" y="6263640"/>
-            <a:ext cx="10698480" cy="320040"/>
+            <a:off x="502920" y="3218688"/>
+            <a:ext cx="11155680" cy="868680"/>
+          </a:xfrm>
+          <a:prstGeom prst="rect">
+            <a:avLst/>
+          </a:prstGeom>
+          <a:noFill/>
+        </p:spPr>
+        <p:txBody>
+          <a:bodyPr wrap="square">
+            <a:spAutoFit/>
+          </a:bodyPr>
+          <a:lstStyle/>
+          <a:p>
+            <a:pPr algn="l"/>
+            <a:r>
+              <a:rPr sz="1700" b="0">
+                <a:solidFill>
+                  <a:srgbClr val="FFFFFF"/>
+                </a:solidFill>
+              </a:rPr>
+              <a:t>▸  Name three workloads where GEAP wins and three where a lighter alternative is preferable</a:t>
+            </a:r>
+          </a:p>
+        </p:txBody>
+      </p:sp>
+      <p:sp>
+        <p:nvSpPr>
+          <p:cNvPr id="9" name="TextBox 8"/>
+          <p:cNvSpPr txBox="1"/>
+          <p:nvPr/>
+        </p:nvSpPr>
+        <p:spPr>
+          <a:xfrm>
+            <a:off x="502920" y="4178808"/>
+            <a:ext cx="11155680" cy="868680"/>
+          </a:xfrm>
+          <a:prstGeom prst="rect">
+            <a:avLst/>
+          </a:prstGeom>
+          <a:noFill/>
+        </p:spPr>
+        <p:txBody>
+          <a:bodyPr wrap="square">
+            <a:spAutoFit/>
+          </a:bodyPr>
+          <a:lstStyle/>
+          <a:p>
+            <a:pPr algn="l"/>
+            <a:r>
+              <a:rPr sz="1700" b="0">
+                <a:solidFill>
+                  <a:srgbClr val="FFFFFF"/>
+                </a:solidFill>
+              </a:rPr>
+              <a:t>▸  Apply a vendor-selection framework to a real-world scenario</a:t>
+            </a:r>
+          </a:p>
+        </p:txBody>
+      </p:sp>
+      <p:sp>
+        <p:nvSpPr>
+          <p:cNvPr id="10" name="TextBox 9"/>
+          <p:cNvSpPr txBox="1"/>
+          <p:nvPr/>
+        </p:nvSpPr>
+        <p:spPr>
+          <a:xfrm>
+            <a:off x="457200" y="6492240"/>
+            <a:ext cx="11247120" cy="320040"/>
           </a:xfrm>
           <a:prstGeom prst="rect">
             <a:avLst/>
@@ -4710,17 +3676,9 @@
 </p:sld>
 </file>
 
-<file path=ppt/slides/slide5.xml><?xml version="1.0" encoding="utf-8"?>
+<file path=ppt/slides/slide3.xml><?xml version="1.0" encoding="utf-8"?>
 <p:sld xmlns:a="http://schemas.openxmlformats.org/drawingml/2006/main" xmlns:p="http://schemas.openxmlformats.org/presentationml/2006/main" xmlns:r="http://schemas.openxmlformats.org/officeDocument/2006/relationships">
   <p:cSld>
-    <p:bg>
-      <p:bgPr>
-        <a:solidFill>
-          <a:srgbClr val="18181B"/>
-        </a:solidFill>
-        <a:effectLst/>
-      </p:bgPr>
-    </p:bg>
     <p:spTree>
       <p:nvGrpSpPr>
         <p:cNvPr id="1" name=""/>
@@ -4730,54 +3688,20 @@
       <p:grpSpPr/>
       <p:sp>
         <p:nvSpPr>
-          <p:cNvPr id="2" name="TextBox 1"/>
-          <p:cNvSpPr txBox="1"/>
-          <p:nvPr/>
-        </p:nvSpPr>
-        <p:spPr>
-          <a:xfrm>
-            <a:off x="731520" y="411480"/>
-            <a:ext cx="10698480" cy="914400"/>
-          </a:xfrm>
-          <a:prstGeom prst="rect">
-            <a:avLst/>
-          </a:prstGeom>
-          <a:noFill/>
-        </p:spPr>
-        <p:txBody>
-          <a:bodyPr wrap="square">
-            <a:spAutoFit/>
-          </a:bodyPr>
-          <a:lstStyle/>
-          <a:p>
-            <a:pPr algn="l"/>
-            <a:r>
-              <a:rPr sz="2700" b="1">
-                <a:solidFill>
-                  <a:srgbClr val="FFFFFF"/>
-                </a:solidFill>
-              </a:rPr>
-              <a:t>Model flexibility</a:t>
-            </a:r>
-          </a:p>
-        </p:txBody>
-      </p:sp>
-      <p:sp>
-        <p:nvSpPr>
-          <p:cNvPr id="3" name="Rectangle 2"/>
+          <p:cNvPr id="2" name="Rectangle 1"/>
           <p:cNvSpPr/>
           <p:nvPr/>
         </p:nvSpPr>
         <p:spPr>
           <a:xfrm>
-            <a:off x="731520" y="1325880"/>
-            <a:ext cx="10698480" cy="36576"/>
+            <a:off x="0" y="0"/>
+            <a:ext cx="12191695" cy="6858000"/>
           </a:xfrm>
           <a:prstGeom prst="rect">
             <a:avLst/>
           </a:prstGeom>
           <a:solidFill>
-            <a:srgbClr val="A1A1AA"/>
+            <a:srgbClr val="18181B"/>
           </a:solidFill>
           <a:ln>
             <a:noFill/>
@@ -4807,182 +3731,20 @@
       </p:sp>
       <p:sp>
         <p:nvSpPr>
-          <p:cNvPr id="4" name="TextBox 3"/>
-          <p:cNvSpPr txBox="1"/>
-          <p:nvPr/>
-        </p:nvSpPr>
-        <p:spPr>
-          <a:xfrm>
-            <a:off x="777240" y="1572768"/>
-            <a:ext cx="10607040" cy="822960"/>
-          </a:xfrm>
-          <a:prstGeom prst="rect">
-            <a:avLst/>
-          </a:prstGeom>
-          <a:noFill/>
-        </p:spPr>
-        <p:txBody>
-          <a:bodyPr wrap="square">
-            <a:spAutoFit/>
-          </a:bodyPr>
-          <a:lstStyle/>
-          <a:p>
-            <a:pPr algn="l"/>
-            <a:r>
-              <a:rPr sz="1700" b="0">
-                <a:solidFill>
-                  <a:srgbClr val="FFFFFF"/>
-                </a:solidFill>
-              </a:rPr>
-              <a:t>• A nuance worth naming: GEAP lists 200+ models including Claude, but features like Agent Optimizer and Memory Bank distillatio</a:t>
-            </a:r>
-          </a:p>
-        </p:txBody>
-      </p:sp>
-      <p:sp>
-        <p:nvSpPr>
-          <p:cNvPr id="5" name="TextBox 4"/>
-          <p:cNvSpPr txBox="1"/>
-          <p:nvPr/>
-        </p:nvSpPr>
-        <p:spPr>
-          <a:xfrm>
-            <a:off x="777240" y="2487168"/>
-            <a:ext cx="10607040" cy="822960"/>
-          </a:xfrm>
-          <a:prstGeom prst="rect">
-            <a:avLst/>
-          </a:prstGeom>
-          <a:noFill/>
-        </p:spPr>
-        <p:txBody>
-          <a:bodyPr wrap="square">
-            <a:spAutoFit/>
-          </a:bodyPr>
-          <a:lstStyle/>
-          <a:p>
-            <a:pPr algn="l"/>
-            <a:r>
-              <a:rPr sz="1700" b="0">
-                <a:solidFill>
-                  <a:srgbClr val="FFFFFF"/>
-                </a:solidFill>
-              </a:rPr>
-              <a:t>• The 200-model promise has a catch. GEAP's model diversity is real for inference. But the Govern and Optimize features — Agent</a:t>
-            </a:r>
-          </a:p>
-        </p:txBody>
-      </p:sp>
-      <p:sp>
-        <p:nvSpPr>
-          <p:cNvPr id="6" name="TextBox 5"/>
-          <p:cNvSpPr txBox="1"/>
-          <p:nvPr/>
-        </p:nvSpPr>
-        <p:spPr>
-          <a:xfrm>
-            <a:off x="731520" y="6263640"/>
-            <a:ext cx="10698480" cy="320040"/>
-          </a:xfrm>
-          <a:prstGeom prst="rect">
-            <a:avLst/>
-          </a:prstGeom>
-          <a:noFill/>
-        </p:spPr>
-        <p:txBody>
-          <a:bodyPr wrap="square">
-            <a:spAutoFit/>
-          </a:bodyPr>
-          <a:lstStyle/>
-          <a:p>
-            <a:pPr algn="l"/>
-            <a:r>
-              <a:rPr sz="1000" b="0">
-                <a:solidFill>
-                  <a:srgbClr val="A1A1AA"/>
-                </a:solidFill>
-              </a:rPr>
-              <a:t>academy.kspl.tech | Koenig AI Academy</a:t>
-            </a:r>
-          </a:p>
-        </p:txBody>
-      </p:sp>
-    </p:spTree>
-  </p:cSld>
-  <p:clrMapOvr>
-    <a:masterClrMapping/>
-  </p:clrMapOvr>
-</p:sld>
-</file>
-
-<file path=ppt/slides/slide6.xml><?xml version="1.0" encoding="utf-8"?>
-<p:sld xmlns:a="http://schemas.openxmlformats.org/drawingml/2006/main" xmlns:p="http://schemas.openxmlformats.org/presentationml/2006/main" xmlns:r="http://schemas.openxmlformats.org/officeDocument/2006/relationships">
-  <p:cSld>
-    <p:bg>
-      <p:bgPr>
-        <a:solidFill>
-          <a:srgbClr val="18181B"/>
-        </a:solidFill>
-        <a:effectLst/>
-      </p:bgPr>
-    </p:bg>
-    <p:spTree>
-      <p:nvGrpSpPr>
-        <p:cNvPr id="1" name=""/>
-        <p:cNvGrpSpPr/>
-        <p:nvPr/>
-      </p:nvGrpSpPr>
-      <p:grpSpPr/>
-      <p:sp>
-        <p:nvSpPr>
-          <p:cNvPr id="2" name="TextBox 1"/>
-          <p:cNvSpPr txBox="1"/>
-          <p:nvPr/>
-        </p:nvSpPr>
-        <p:spPr>
-          <a:xfrm>
-            <a:off x="731520" y="411480"/>
-            <a:ext cx="10698480" cy="914400"/>
-          </a:xfrm>
-          <a:prstGeom prst="rect">
-            <a:avLst/>
-          </a:prstGeom>
-          <a:noFill/>
-        </p:spPr>
-        <p:txBody>
-          <a:bodyPr wrap="square">
-            <a:spAutoFit/>
-          </a:bodyPr>
-          <a:lstStyle/>
-          <a:p>
-            <a:pPr algn="l"/>
-            <a:r>
-              <a:rPr sz="2700" b="1">
-                <a:solidFill>
-                  <a:srgbClr val="FFFFFF"/>
-                </a:solidFill>
-              </a:rPr>
-              <a:t>Lock-in surface area</a:t>
-            </a:r>
-          </a:p>
-        </p:txBody>
-      </p:sp>
-      <p:sp>
-        <p:nvSpPr>
           <p:cNvPr id="3" name="Rectangle 2"/>
           <p:cNvSpPr/>
           <p:nvPr/>
         </p:nvSpPr>
         <p:spPr>
           <a:xfrm>
-            <a:off x="731520" y="1325880"/>
-            <a:ext cx="10698480" cy="36576"/>
+            <a:off x="0" y="0"/>
+            <a:ext cx="12191695" cy="54864"/>
           </a:xfrm>
           <a:prstGeom prst="rect">
             <a:avLst/>
           </a:prstGeom>
           <a:solidFill>
-            <a:srgbClr val="A1A1AA"/>
+            <a:srgbClr val="6366F1"/>
           </a:solidFill>
           <a:ln>
             <a:noFill/>
@@ -5018,8 +3780,8 @@
         </p:nvSpPr>
         <p:spPr>
           <a:xfrm>
-            <a:off x="777240" y="1572768"/>
-            <a:ext cx="10607040" cy="822960"/>
+            <a:off x="457200" y="164592"/>
+            <a:ext cx="11247120" cy="868680"/>
           </a:xfrm>
           <a:prstGeom prst="rect">
             <a:avLst/>
@@ -5034,256 +3796,26 @@
           <a:p>
             <a:pPr algn="l"/>
             <a:r>
-              <a:rPr sz="1700" b="0">
+              <a:rPr sz="2800" b="1">
                 <a:solidFill>
                   <a:srgbClr val="FFFFFF"/>
                 </a:solidFill>
               </a:rPr>
-              <a:t>• This is the most important section for anyone building a production system. Lock-in is not binary — it is a spectrum. The que</a:t>
-            </a:r>
-          </a:p>
-        </p:txBody>
-      </p:sp>
-      <p:sp>
-        <p:nvSpPr>
-          <p:cNvPr id="5" name="TextBox 4"/>
-          <p:cNvSpPr txBox="1"/>
-          <p:nvPr/>
-        </p:nvSpPr>
-        <p:spPr>
-          <a:xfrm>
-            <a:off x="777240" y="2487168"/>
-            <a:ext cx="10607040" cy="822960"/>
-          </a:xfrm>
-          <a:prstGeom prst="rect">
-            <a:avLst/>
-          </a:prstGeom>
-          <a:noFill/>
-        </p:spPr>
-        <p:txBody>
-          <a:bodyPr wrap="square">
-            <a:spAutoFit/>
-          </a:bodyPr>
-          <a:lstStyle/>
-          <a:p>
-            <a:pPr algn="l"/>
-            <a:r>
-              <a:rPr sz="1700" b="0">
-                <a:solidFill>
-                  <a:srgbClr val="FFFFFF"/>
-                </a:solidFill>
-              </a:rPr>
-              <a:t>• GEAP lock-in surface</a:t>
-            </a:r>
-          </a:p>
-        </p:txBody>
-      </p:sp>
-      <p:sp>
-        <p:nvSpPr>
-          <p:cNvPr id="6" name="TextBox 5"/>
-          <p:cNvSpPr txBox="1"/>
-          <p:nvPr/>
-        </p:nvSpPr>
-        <p:spPr>
-          <a:xfrm>
-            <a:off x="777240" y="3401568"/>
-            <a:ext cx="10607040" cy="822960"/>
-          </a:xfrm>
-          <a:prstGeom prst="rect">
-            <a:avLst/>
-          </a:prstGeom>
-          <a:noFill/>
-        </p:spPr>
-        <p:txBody>
-          <a:bodyPr wrap="square">
-            <a:spAutoFit/>
-          </a:bodyPr>
-          <a:lstStyle/>
-          <a:p>
-            <a:pPr algn="l"/>
-            <a:r>
-              <a:rPr sz="1700" b="0">
-                <a:solidFill>
-                  <a:srgbClr val="FFFFFF"/>
-                </a:solidFill>
-              </a:rPr>
-              <a:t>• High. The ADK is Apache 2.0 and portable. But:</a:t>
-            </a:r>
-          </a:p>
-        </p:txBody>
-      </p:sp>
-      <p:sp>
-        <p:nvSpPr>
-          <p:cNvPr id="7" name="TextBox 6"/>
-          <p:cNvSpPr txBox="1"/>
-          <p:nvPr/>
-        </p:nvSpPr>
-        <p:spPr>
-          <a:xfrm>
-            <a:off x="777240" y="4315968"/>
-            <a:ext cx="10607040" cy="822960"/>
-          </a:xfrm>
-          <a:prstGeom prst="rect">
-            <a:avLst/>
-          </a:prstGeom>
-          <a:noFill/>
-        </p:spPr>
-        <p:txBody>
-          <a:bodyPr wrap="square">
-            <a:spAutoFit/>
-          </a:bodyPr>
-          <a:lstStyle/>
-          <a:p>
-            <a:pPr algn="l"/>
-            <a:r>
-              <a:rPr sz="1700" b="0">
-                <a:solidFill>
-                  <a:srgbClr val="FFFFFF"/>
-                </a:solidFill>
-              </a:rPr>
-              <a:t>• Memory Bank: proprietary GCP service, no export API at launch</a:t>
-            </a:r>
-          </a:p>
-        </p:txBody>
-      </p:sp>
-      <p:sp>
-        <p:nvSpPr>
-          <p:cNvPr id="8" name="TextBox 7"/>
-          <p:cNvSpPr txBox="1"/>
-          <p:nvPr/>
-        </p:nvSpPr>
-        <p:spPr>
-          <a:xfrm>
-            <a:off x="777240" y="5230368"/>
-            <a:ext cx="10607040" cy="822960"/>
-          </a:xfrm>
-          <a:prstGeom prst="rect">
-            <a:avLst/>
-          </a:prstGeom>
-          <a:noFill/>
-        </p:spPr>
-        <p:txBody>
-          <a:bodyPr wrap="square">
-            <a:spAutoFit/>
-          </a:bodyPr>
-          <a:lstStyle/>
-          <a:p>
-            <a:pPr algn="l"/>
-            <a:r>
-              <a:rPr sz="1700" b="0">
-                <a:solidFill>
-                  <a:srgbClr val="FFFFFF"/>
-                </a:solidFill>
-              </a:rPr>
-              <a:t>• Agent Registry: your tool and agent catalogue lives in GCP</a:t>
-            </a:r>
-          </a:p>
-        </p:txBody>
-      </p:sp>
-      <p:sp>
-        <p:nvSpPr>
-          <p:cNvPr id="9" name="TextBox 8"/>
-          <p:cNvSpPr txBox="1"/>
-          <p:nvPr/>
-        </p:nvSpPr>
-        <p:spPr>
-          <a:xfrm>
-            <a:off x="731520" y="6263640"/>
-            <a:ext cx="10698480" cy="320040"/>
-          </a:xfrm>
-          <a:prstGeom prst="rect">
-            <a:avLst/>
-          </a:prstGeom>
-          <a:noFill/>
-        </p:spPr>
-        <p:txBody>
-          <a:bodyPr wrap="square">
-            <a:spAutoFit/>
-          </a:bodyPr>
-          <a:lstStyle/>
-          <a:p>
-            <a:pPr algn="l"/>
-            <a:r>
-              <a:rPr sz="1000" b="0">
-                <a:solidFill>
-                  <a:srgbClr val="A1A1AA"/>
-                </a:solidFill>
-              </a:rPr>
-              <a:t>academy.kspl.tech | Koenig AI Academy</a:t>
-            </a:r>
-          </a:p>
-        </p:txBody>
-      </p:sp>
-    </p:spTree>
-  </p:cSld>
-  <p:clrMapOvr>
-    <a:masterClrMapping/>
-  </p:clrMapOvr>
-</p:sld>
-</file>
-
-<file path=ppt/slides/slide7.xml><?xml version="1.0" encoding="utf-8"?>
-<p:sld xmlns:a="http://schemas.openxmlformats.org/drawingml/2006/main" xmlns:p="http://schemas.openxmlformats.org/presentationml/2006/main" xmlns:r="http://schemas.openxmlformats.org/officeDocument/2006/relationships">
-  <p:cSld>
-    <p:bg>
-      <p:bgPr>
-        <a:solidFill>
-          <a:srgbClr val="18181B"/>
-        </a:solidFill>
-        <a:effectLst/>
-      </p:bgPr>
-    </p:bg>
-    <p:spTree>
-      <p:nvGrpSpPr>
-        <p:cNvPr id="1" name=""/>
-        <p:cNvGrpSpPr/>
-        <p:nvPr/>
-      </p:nvGrpSpPr>
-      <p:grpSpPr/>
-      <p:sp>
-        <p:nvSpPr>
-          <p:cNvPr id="2" name="TextBox 1"/>
-          <p:cNvSpPr txBox="1"/>
-          <p:nvPr/>
-        </p:nvSpPr>
-        <p:spPr>
-          <a:xfrm>
-            <a:off x="731520" y="411480"/>
-            <a:ext cx="10698480" cy="914400"/>
-          </a:xfrm>
-          <a:prstGeom prst="rect">
-            <a:avLst/>
-          </a:prstGeom>
-          <a:noFill/>
-        </p:spPr>
-        <p:txBody>
-          <a:bodyPr wrap="square">
-            <a:spAutoFit/>
-          </a:bodyPr>
-          <a:lstStyle/>
-          <a:p>
-            <a:pPr algn="l"/>
-            <a:r>
-              <a:rPr sz="2700" b="1">
-                <a:solidFill>
-                  <a:srgbClr val="FFFFFF"/>
-                </a:solidFill>
-              </a:rPr>
-              <a:t>Decision framework: which platform for which workload</a:t>
-            </a:r>
-          </a:p>
-        </p:txBody>
-      </p:sp>
-      <p:sp>
-        <p:nvSpPr>
-          <p:cNvPr id="3" name="Rectangle 2"/>
+              <a:t>Platform Overview — Three Approaches</a:t>
+            </a:r>
+          </a:p>
+        </p:txBody>
+      </p:sp>
+      <p:sp>
+        <p:nvSpPr>
+          <p:cNvPr id="5" name="Rectangle 4"/>
           <p:cNvSpPr/>
           <p:nvPr/>
         </p:nvSpPr>
         <p:spPr>
           <a:xfrm>
-            <a:off x="731520" y="1325880"/>
-            <a:ext cx="10698480" cy="36576"/>
+            <a:off x="457200" y="1143000"/>
+            <a:ext cx="11247120" cy="27432"/>
           </a:xfrm>
           <a:prstGeom prst="rect">
             <a:avLst/>
@@ -5319,14 +3851,14 @@
       </p:sp>
       <p:sp>
         <p:nvSpPr>
-          <p:cNvPr id="4" name="TextBox 3"/>
+          <p:cNvPr id="6" name="TextBox 5"/>
           <p:cNvSpPr txBox="1"/>
           <p:nvPr/>
         </p:nvSpPr>
         <p:spPr>
           <a:xfrm>
-            <a:off x="777240" y="1572768"/>
-            <a:ext cx="10607040" cy="822960"/>
+            <a:off x="502920" y="1298448"/>
+            <a:ext cx="11155680" cy="731520"/>
           </a:xfrm>
           <a:prstGeom prst="rect">
             <a:avLst/>
@@ -5341,26 +3873,26 @@
           <a:p>
             <a:pPr algn="l"/>
             <a:r>
-              <a:rPr sz="1700" b="0">
+              <a:rPr sz="1500" b="0">
                 <a:solidFill>
                   <a:srgbClr val="FFFFFF"/>
                 </a:solidFill>
               </a:rPr>
-              <a:t>• Use this framework when you are choosing a platform for a new agent workload.</a:t>
-            </a:r>
-          </a:p>
-        </p:txBody>
-      </p:sp>
-      <p:sp>
-        <p:nvSpPr>
-          <p:cNvPr id="5" name="TextBox 4"/>
+              <a:t>▸  GEAP: fully managed and opinionated — state via Agent Sessions + Memory Bank, runs on GCP</a:t>
+            </a:r>
+          </a:p>
+        </p:txBody>
+      </p:sp>
+      <p:sp>
+        <p:nvSpPr>
+          <p:cNvPr id="7" name="TextBox 6"/>
           <p:cNvSpPr txBox="1"/>
           <p:nvPr/>
         </p:nvSpPr>
         <p:spPr>
           <a:xfrm>
-            <a:off x="777240" y="2487168"/>
-            <a:ext cx="10607040" cy="822960"/>
+            <a:off x="502920" y="2121408"/>
+            <a:ext cx="11155680" cy="731520"/>
           </a:xfrm>
           <a:prstGeom prst="rect">
             <a:avLst/>
@@ -5375,26 +3907,26 @@
           <a:p>
             <a:pPr algn="l"/>
             <a:r>
-              <a:rPr sz="1700" b="0">
+              <a:rPr sz="1500" b="0">
                 <a:solidFill>
                   <a:srgbClr val="FFFFFF"/>
                 </a:solidFill>
               </a:rPr>
-              <a:t>• Choose GEAP when</a:t>
-            </a:r>
-          </a:p>
-        </p:txBody>
-      </p:sp>
-      <p:sp>
-        <p:nvSpPr>
-          <p:cNvPr id="6" name="TextBox 5"/>
+              <a:t>▸  Claude Agent SDK: code-first, least opinionated — you own infra, state, and deployment entirely</a:t>
+            </a:r>
+          </a:p>
+        </p:txBody>
+      </p:sp>
+      <p:sp>
+        <p:nvSpPr>
+          <p:cNvPr id="8" name="TextBox 7"/>
           <p:cNvSpPr txBox="1"/>
           <p:nvPr/>
         </p:nvSpPr>
         <p:spPr>
           <a:xfrm>
-            <a:off x="777240" y="3401568"/>
-            <a:ext cx="10607040" cy="822960"/>
+            <a:off x="502920" y="2944368"/>
+            <a:ext cx="11155680" cy="731520"/>
           </a:xfrm>
           <a:prstGeom prst="rect">
             <a:avLst/>
@@ -5409,26 +3941,26 @@
           <a:p>
             <a:pPr algn="l"/>
             <a:r>
-              <a:rPr sz="1700" b="0">
+              <a:rPr sz="1500" b="0">
                 <a:solidFill>
                   <a:srgbClr val="FFFFFF"/>
                 </a:solidFill>
               </a:rPr>
-              <a:t>• You are already on GCP and your data is in BigQuery, Cloud SQL, or GCS. The integration story is compelling — your agents rea</a:t>
-            </a:r>
-          </a:p>
-        </p:txBody>
-      </p:sp>
-      <p:sp>
-        <p:nvSpPr>
-          <p:cNvPr id="7" name="TextBox 6"/>
+              <a:t>▸  Cloudflare Agents: TypeScript SDK on Workers — built-in SQLite state, 300+ edge PoPs, sub-ms cold starts</a:t>
+            </a:r>
+          </a:p>
+        </p:txBody>
+      </p:sp>
+      <p:sp>
+        <p:nvSpPr>
+          <p:cNvPr id="9" name="TextBox 8"/>
           <p:cNvSpPr txBox="1"/>
           <p:nvPr/>
         </p:nvSpPr>
         <p:spPr>
           <a:xfrm>
-            <a:off x="777240" y="4315968"/>
-            <a:ext cx="10607040" cy="822960"/>
+            <a:off x="502920" y="3767328"/>
+            <a:ext cx="11155680" cy="731520"/>
           </a:xfrm>
           <a:prstGeom prst="rect">
             <a:avLst/>
@@ -5443,26 +3975,26 @@
           <a:p>
             <a:pPr algn="l"/>
             <a:r>
-              <a:rPr sz="1700" b="0">
+              <a:rPr sz="1500" b="0">
                 <a:solidFill>
                   <a:srgbClr val="FFFFFF"/>
                 </a:solidFill>
               </a:rPr>
-              <a:t>• You need enterprise governance. Agent Identity, Agent Anomaly Detection, and Security Command Center integration are producti</a:t>
-            </a:r>
-          </a:p>
-        </p:txBody>
-      </p:sp>
-      <p:sp>
-        <p:nvSpPr>
-          <p:cNvPr id="8" name="TextBox 7"/>
+              <a:t>▸  All three support tool calling, multi-agent patterns, and long-running agents</a:t>
+            </a:r>
+          </a:p>
+        </p:txBody>
+      </p:sp>
+      <p:sp>
+        <p:nvSpPr>
+          <p:cNvPr id="10" name="TextBox 9"/>
           <p:cNvSpPr txBox="1"/>
           <p:nvPr/>
         </p:nvSpPr>
         <p:spPr>
           <a:xfrm>
-            <a:off x="777240" y="5230368"/>
-            <a:ext cx="10607040" cy="822960"/>
+            <a:off x="502920" y="4590288"/>
+            <a:ext cx="11155680" cy="731520"/>
           </a:xfrm>
           <a:prstGeom prst="rect">
             <a:avLst/>
@@ -5477,26 +4009,26 @@
           <a:p>
             <a:pPr algn="l"/>
             <a:r>
-              <a:rPr sz="1700" b="0">
+              <a:rPr sz="1500" b="0">
                 <a:solidFill>
                   <a:srgbClr val="FFFFFF"/>
                 </a:solidFill>
               </a:rPr>
-              <a:t>• You are building a multi-agent system with 5+ agents. Agent Registry, Agent Gateway, and the Govern pillar were designed for </a:t>
-            </a:r>
-          </a:p>
-        </p:txBody>
-      </p:sp>
-      <p:sp>
-        <p:nvSpPr>
-          <p:cNvPr id="9" name="TextBox 8"/>
+              <a:t>▸  Key divergence: state management is the sharpest architectural difference between platforms</a:t>
+            </a:r>
+          </a:p>
+        </p:txBody>
+      </p:sp>
+      <p:sp>
+        <p:nvSpPr>
+          <p:cNvPr id="11" name="TextBox 10"/>
           <p:cNvSpPr txBox="1"/>
           <p:nvPr/>
         </p:nvSpPr>
         <p:spPr>
           <a:xfrm>
-            <a:off x="731520" y="6263640"/>
-            <a:ext cx="10698480" cy="320040"/>
+            <a:off x="457200" y="6492240"/>
+            <a:ext cx="11247120" cy="320040"/>
           </a:xfrm>
           <a:prstGeom prst="rect">
             <a:avLst/>
@@ -5529,17 +4061,9 @@
 </p:sld>
 </file>
 
-<file path=ppt/slides/slide8.xml><?xml version="1.0" encoding="utf-8"?>
+<file path=ppt/slides/slide4.xml><?xml version="1.0" encoding="utf-8"?>
 <p:sld xmlns:a="http://schemas.openxmlformats.org/drawingml/2006/main" xmlns:p="http://schemas.openxmlformats.org/presentationml/2006/main" xmlns:r="http://schemas.openxmlformats.org/officeDocument/2006/relationships">
   <p:cSld>
-    <p:bg>
-      <p:bgPr>
-        <a:solidFill>
-          <a:srgbClr val="18181B"/>
-        </a:solidFill>
-        <a:effectLst/>
-      </p:bgPr>
-    </p:bg>
     <p:spTree>
       <p:nvGrpSpPr>
         <p:cNvPr id="1" name=""/>
@@ -5549,54 +4073,20 @@
       <p:grpSpPr/>
       <p:sp>
         <p:nvSpPr>
-          <p:cNvPr id="2" name="TextBox 1"/>
-          <p:cNvSpPr txBox="1"/>
-          <p:nvPr/>
-        </p:nvSpPr>
-        <p:spPr>
-          <a:xfrm>
-            <a:off x="731520" y="411480"/>
-            <a:ext cx="10698480" cy="914400"/>
-          </a:xfrm>
-          <a:prstGeom prst="rect">
-            <a:avLst/>
-          </a:prstGeom>
-          <a:noFill/>
-        </p:spPr>
-        <p:txBody>
-          <a:bodyPr wrap="square">
-            <a:spAutoFit/>
-          </a:bodyPr>
-          <a:lstStyle/>
-          <a:p>
-            <a:pPr algn="l"/>
-            <a:r>
-              <a:rPr sz="2700" b="1">
-                <a:solidFill>
-                  <a:srgbClr val="FFFFFF"/>
-                </a:solidFill>
-              </a:rPr>
-              <a:t>The hybrid approach</a:t>
-            </a:r>
-          </a:p>
-        </p:txBody>
-      </p:sp>
-      <p:sp>
-        <p:nvSpPr>
-          <p:cNvPr id="3" name="Rectangle 2"/>
+          <p:cNvPr id="2" name="Rectangle 1"/>
           <p:cNvSpPr/>
           <p:nvPr/>
         </p:nvSpPr>
         <p:spPr>
           <a:xfrm>
-            <a:off x="731520" y="1325880"/>
-            <a:ext cx="10698480" cy="36576"/>
+            <a:off x="0" y="0"/>
+            <a:ext cx="12191695" cy="6858000"/>
           </a:xfrm>
           <a:prstGeom prst="rect">
             <a:avLst/>
           </a:prstGeom>
           <a:solidFill>
-            <a:srgbClr val="A1A1AA"/>
+            <a:srgbClr val="18181B"/>
           </a:solidFill>
           <a:ln>
             <a:noFill/>
@@ -5626,284 +4116,20 @@
       </p:sp>
       <p:sp>
         <p:nvSpPr>
-          <p:cNvPr id="4" name="TextBox 3"/>
-          <p:cNvSpPr txBox="1"/>
-          <p:nvPr/>
-        </p:nvSpPr>
-        <p:spPr>
-          <a:xfrm>
-            <a:off x="777240" y="1572768"/>
-            <a:ext cx="10607040" cy="822960"/>
-          </a:xfrm>
-          <a:prstGeom prst="rect">
-            <a:avLst/>
-          </a:prstGeom>
-          <a:noFill/>
-        </p:spPr>
-        <p:txBody>
-          <a:bodyPr wrap="square">
-            <a:spAutoFit/>
-          </a:bodyPr>
-          <a:lstStyle/>
-          <a:p>
-            <a:pPr algn="l"/>
-            <a:r>
-              <a:rPr sz="1700" b="0">
-                <a:solidFill>
-                  <a:srgbClr val="FFFFFF"/>
-                </a:solidFill>
-              </a:rPr>
-              <a:t>• Nothing in these three platforms is mutually exclusive. The most sophisticated production setups mix them:</a:t>
-            </a:r>
-          </a:p>
-        </p:txBody>
-      </p:sp>
-      <p:sp>
-        <p:nvSpPr>
-          <p:cNvPr id="5" name="TextBox 4"/>
-          <p:cNvSpPr txBox="1"/>
-          <p:nvPr/>
-        </p:nvSpPr>
-        <p:spPr>
-          <a:xfrm>
-            <a:off x="777240" y="2487168"/>
-            <a:ext cx="10607040" cy="822960"/>
-          </a:xfrm>
-          <a:prstGeom prst="rect">
-            <a:avLst/>
-          </a:prstGeom>
-          <a:noFill/>
-        </p:spPr>
-        <p:txBody>
-          <a:bodyPr wrap="square">
-            <a:spAutoFit/>
-          </a:bodyPr>
-          <a:lstStyle/>
-          <a:p>
-            <a:pPr algn="l"/>
-            <a:r>
-              <a:rPr sz="1700" b="0">
-                <a:solidFill>
-                  <a:srgbClr val="FFFFFF"/>
-                </a:solidFill>
-              </a:rPr>
-              <a:t>• GEAP orchestration + Claude sub-agents: Use Agent Registry and Agent Gateway for governance, but route specific high-stakes d</a:t>
-            </a:r>
-          </a:p>
-        </p:txBody>
-      </p:sp>
-      <p:sp>
-        <p:nvSpPr>
-          <p:cNvPr id="6" name="TextBox 5"/>
-          <p:cNvSpPr txBox="1"/>
-          <p:nvPr/>
-        </p:nvSpPr>
-        <p:spPr>
-          <a:xfrm>
-            <a:off x="777240" y="3401568"/>
-            <a:ext cx="10607040" cy="822960"/>
-          </a:xfrm>
-          <a:prstGeom prst="rect">
-            <a:avLst/>
-          </a:prstGeom>
-          <a:noFill/>
-        </p:spPr>
-        <p:txBody>
-          <a:bodyPr wrap="square">
-            <a:spAutoFit/>
-          </a:bodyPr>
-          <a:lstStyle/>
-          <a:p>
-            <a:pPr algn="l"/>
-            <a:r>
-              <a:rPr sz="1700" b="0">
-                <a:solidFill>
-                  <a:srgbClr val="FFFFFF"/>
-                </a:solidFill>
-              </a:rPr>
-              <a:t>• Cloudflare edge + GEAP backend: Real-time WebSocket connection via Cloudflare Agents for &lt;50ms user-facing latency, with heav</a:t>
-            </a:r>
-          </a:p>
-        </p:txBody>
-      </p:sp>
-      <p:sp>
-        <p:nvSpPr>
-          <p:cNvPr id="7" name="TextBox 6"/>
-          <p:cNvSpPr txBox="1"/>
-          <p:nvPr/>
-        </p:nvSpPr>
-        <p:spPr>
-          <a:xfrm>
-            <a:off x="777240" y="4315968"/>
-            <a:ext cx="10607040" cy="822960"/>
-          </a:xfrm>
-          <a:prstGeom prst="rect">
-            <a:avLst/>
-          </a:prstGeom>
-          <a:noFill/>
-        </p:spPr>
-        <p:txBody>
-          <a:bodyPr wrap="square">
-            <a:spAutoFit/>
-          </a:bodyPr>
-          <a:lstStyle/>
-          <a:p>
-            <a:pPr algn="l"/>
-            <a:r>
-              <a:rPr sz="1700" b="0">
-                <a:solidFill>
-                  <a:srgbClr val="FFFFFF"/>
-                </a:solidFill>
-              </a:rPr>
-              <a:t>• Claude SDK + Cloudflare state: Use Claude for reasoning, Cloudflare Durable Objects as a simple, co-located state store, depl</a:t>
-            </a:r>
-          </a:p>
-        </p:txBody>
-      </p:sp>
-      <p:sp>
-        <p:nvSpPr>
-          <p:cNvPr id="8" name="TextBox 7"/>
-          <p:cNvSpPr txBox="1"/>
-          <p:nvPr/>
-        </p:nvSpPr>
-        <p:spPr>
-          <a:xfrm>
-            <a:off x="777240" y="5230368"/>
-            <a:ext cx="10607040" cy="822960"/>
-          </a:xfrm>
-          <a:prstGeom prst="rect">
-            <a:avLst/>
-          </a:prstGeom>
-          <a:noFill/>
-        </p:spPr>
-        <p:txBody>
-          <a:bodyPr wrap="square">
-            <a:spAutoFit/>
-          </a:bodyPr>
-          <a:lstStyle/>
-          <a:p>
-            <a:pPr algn="l"/>
-            <a:r>
-              <a:rPr sz="1700" b="0">
-                <a:solidFill>
-                  <a:srgbClr val="FFFFFF"/>
-                </a:solidFill>
-              </a:rPr>
-              <a:t>• The lock-in analysis applies to each layer independently. You can use GEAP's agent governance while keeping your raw data in </a:t>
-            </a:r>
-          </a:p>
-        </p:txBody>
-      </p:sp>
-      <p:sp>
-        <p:nvSpPr>
-          <p:cNvPr id="9" name="TextBox 8"/>
-          <p:cNvSpPr txBox="1"/>
-          <p:nvPr/>
-        </p:nvSpPr>
-        <p:spPr>
-          <a:xfrm>
-            <a:off x="731520" y="6263640"/>
-            <a:ext cx="10698480" cy="320040"/>
-          </a:xfrm>
-          <a:prstGeom prst="rect">
-            <a:avLst/>
-          </a:prstGeom>
-          <a:noFill/>
-        </p:spPr>
-        <p:txBody>
-          <a:bodyPr wrap="square">
-            <a:spAutoFit/>
-          </a:bodyPr>
-          <a:lstStyle/>
-          <a:p>
-            <a:pPr algn="l"/>
-            <a:r>
-              <a:rPr sz="1000" b="0">
-                <a:solidFill>
-                  <a:srgbClr val="A1A1AA"/>
-                </a:solidFill>
-              </a:rPr>
-              <a:t>academy.kspl.tech | Koenig AI Academy</a:t>
-            </a:r>
-          </a:p>
-        </p:txBody>
-      </p:sp>
-    </p:spTree>
-  </p:cSld>
-  <p:clrMapOvr>
-    <a:masterClrMapping/>
-  </p:clrMapOvr>
-</p:sld>
-</file>
-
-<file path=ppt/slides/slide9.xml><?xml version="1.0" encoding="utf-8"?>
-<p:sld xmlns:a="http://schemas.openxmlformats.org/drawingml/2006/main" xmlns:p="http://schemas.openxmlformats.org/presentationml/2006/main" xmlns:r="http://schemas.openxmlformats.org/officeDocument/2006/relationships">
-  <p:cSld>
-    <p:bg>
-      <p:bgPr>
-        <a:solidFill>
-          <a:srgbClr val="18181B"/>
-        </a:solidFill>
-        <a:effectLst/>
-      </p:bgPr>
-    </p:bg>
-    <p:spTree>
-      <p:nvGrpSpPr>
-        <p:cNvPr id="1" name=""/>
-        <p:cNvGrpSpPr/>
-        <p:nvPr/>
-      </p:nvGrpSpPr>
-      <p:grpSpPr/>
-      <p:sp>
-        <p:nvSpPr>
-          <p:cNvPr id="2" name="TextBox 1"/>
-          <p:cNvSpPr txBox="1"/>
-          <p:nvPr/>
-        </p:nvSpPr>
-        <p:spPr>
-          <a:xfrm>
-            <a:off x="731520" y="411480"/>
-            <a:ext cx="10698480" cy="914400"/>
-          </a:xfrm>
-          <a:prstGeom prst="rect">
-            <a:avLst/>
-          </a:prstGeom>
-          <a:noFill/>
-        </p:spPr>
-        <p:txBody>
-          <a:bodyPr wrap="square">
-            <a:spAutoFit/>
-          </a:bodyPr>
-          <a:lstStyle/>
-          <a:p>
-            <a:pPr algn="l"/>
-            <a:r>
-              <a:rPr sz="2700" b="1">
-                <a:solidFill>
-                  <a:srgbClr val="FFFFFF"/>
-                </a:solidFill>
-              </a:rPr>
-              <a:t>Hands-on exercise: Map the budget tracker to three platforms</a:t>
-            </a:r>
-          </a:p>
-        </p:txBody>
-      </p:sp>
-      <p:sp>
-        <p:nvSpPr>
           <p:cNvPr id="3" name="Rectangle 2"/>
           <p:cNvSpPr/>
           <p:nvPr/>
         </p:nvSpPr>
         <p:spPr>
           <a:xfrm>
-            <a:off x="731520" y="1325880"/>
-            <a:ext cx="10698480" cy="36576"/>
+            <a:off x="0" y="0"/>
+            <a:ext cx="12191695" cy="54864"/>
           </a:xfrm>
           <a:prstGeom prst="rect">
             <a:avLst/>
           </a:prstGeom>
           <a:solidFill>
-            <a:srgbClr val="A1A1AA"/>
+            <a:srgbClr val="6366F1"/>
           </a:solidFill>
           <a:ln>
             <a:noFill/>
@@ -5939,8 +4165,8 @@
         </p:nvSpPr>
         <p:spPr>
           <a:xfrm>
-            <a:off x="777240" y="1572768"/>
-            <a:ext cx="10607040" cy="822960"/>
+            <a:off x="457200" y="164592"/>
+            <a:ext cx="11247120" cy="868680"/>
           </a:xfrm>
           <a:prstGeom prst="rect">
             <a:avLst/>
@@ -5955,26 +4181,69 @@
           <a:p>
             <a:pPr algn="l"/>
             <a:r>
-              <a:rPr sz="1700" b="0">
+              <a:rPr sz="2800" b="1">
                 <a:solidFill>
                   <a:srgbClr val="FFFFFF"/>
                 </a:solidFill>
               </a:rPr>
-              <a:t>• Goal: Understand what changes and what stays the same when you move an agent across platforms — without writing code.</a:t>
-            </a:r>
-          </a:p>
-        </p:txBody>
-      </p:sp>
-      <p:sp>
-        <p:nvSpPr>
-          <p:cNvPr id="5" name="TextBox 4"/>
+              <a:t>State Management — Deepest Divergence</a:t>
+            </a:r>
+          </a:p>
+        </p:txBody>
+      </p:sp>
+      <p:sp>
+        <p:nvSpPr>
+          <p:cNvPr id="5" name="Rectangle 4"/>
+          <p:cNvSpPr/>
+          <p:nvPr/>
+        </p:nvSpPr>
+        <p:spPr>
+          <a:xfrm>
+            <a:off x="457200" y="1143000"/>
+            <a:ext cx="11247120" cy="27432"/>
+          </a:xfrm>
+          <a:prstGeom prst="rect">
+            <a:avLst/>
+          </a:prstGeom>
+          <a:solidFill>
+            <a:srgbClr val="A1A1AA"/>
+          </a:solidFill>
+          <a:ln>
+            <a:noFill/>
+          </a:ln>
+        </p:spPr>
+        <p:style>
+          <a:lnRef idx="1">
+            <a:schemeClr val="accent1"/>
+          </a:lnRef>
+          <a:fillRef idx="3">
+            <a:schemeClr val="accent1"/>
+          </a:fillRef>
+          <a:effectRef idx="2">
+            <a:schemeClr val="accent1"/>
+          </a:effectRef>
+          <a:fontRef idx="minor">
+            <a:schemeClr val="lt1"/>
+          </a:fontRef>
+        </p:style>
+        <p:txBody>
+          <a:bodyPr rtlCol="0" anchor="ctr"/>
+          <a:lstStyle/>
+          <a:p>
+            <a:pPr algn="ctr"/>
+          </a:p>
+        </p:txBody>
+      </p:sp>
+      <p:sp>
+        <p:nvSpPr>
+          <p:cNvPr id="6" name="TextBox 5"/>
           <p:cNvSpPr txBox="1"/>
           <p:nvPr/>
         </p:nvSpPr>
         <p:spPr>
           <a:xfrm>
-            <a:off x="777240" y="2487168"/>
-            <a:ext cx="10607040" cy="822960"/>
+            <a:off x="502920" y="1298448"/>
+            <a:ext cx="11155680" cy="731520"/>
           </a:xfrm>
           <a:prstGeom prst="rect">
             <a:avLst/>
@@ -5989,26 +4258,26 @@
           <a:p>
             <a:pPr algn="l"/>
             <a:r>
-              <a:rPr sz="1700" b="0">
+              <a:rPr sz="1500" b="0">
                 <a:solidFill>
                   <a:srgbClr val="FFFFFF"/>
                 </a:solidFill>
               </a:rPr>
-              <a:t>• Take the budget tracker agent from Chapter 2 (the agent with log_expense, get_expense_summary, and session state). For each o</a:t>
-            </a:r>
-          </a:p>
-        </p:txBody>
-      </p:sp>
-      <p:sp>
-        <p:nvSpPr>
-          <p:cNvPr id="6" name="TextBox 5"/>
+              <a:t>▸  GEAP: platform manages state via Agent Sessions and Memory Bank — no schema work, but GCP-locked</a:t>
+            </a:r>
+          </a:p>
+        </p:txBody>
+      </p:sp>
+      <p:sp>
+        <p:nvSpPr>
+          <p:cNvPr id="7" name="TextBox 6"/>
           <p:cNvSpPr txBox="1"/>
           <p:nvPr/>
         </p:nvSpPr>
         <p:spPr>
           <a:xfrm>
-            <a:off x="777240" y="3401568"/>
-            <a:ext cx="10607040" cy="822960"/>
+            <a:off x="502920" y="2121408"/>
+            <a:ext cx="11155680" cy="731520"/>
           </a:xfrm>
           <a:prstGeom prst="rect">
             <a:avLst/>
@@ -6023,26 +4292,26 @@
           <a:p>
             <a:pPr algn="l"/>
             <a:r>
-              <a:rPr sz="1700" b="0">
+              <a:rPr sz="1500" b="0">
                 <a:solidFill>
                   <a:srgbClr val="FFFFFF"/>
                 </a:solidFill>
               </a:rPr>
-              <a:t>• GEAP (you already built this):</a:t>
-            </a:r>
-          </a:p>
-        </p:txBody>
-      </p:sp>
-      <p:sp>
-        <p:nvSpPr>
-          <p:cNvPr id="7" name="TextBox 6"/>
+              <a:t>▸  Claude SDK: you manage everything — conversation history, long-term memory, and context compression</a:t>
+            </a:r>
+          </a:p>
+        </p:txBody>
+      </p:sp>
+      <p:sp>
+        <p:nvSpPr>
+          <p:cNvPr id="8" name="TextBox 7"/>
           <p:cNvSpPr txBox="1"/>
           <p:nvPr/>
         </p:nvSpPr>
         <p:spPr>
           <a:xfrm>
-            <a:off x="777240" y="4315968"/>
-            <a:ext cx="10607040" cy="822960"/>
+            <a:off x="502920" y="2944368"/>
+            <a:ext cx="11155680" cy="731520"/>
           </a:xfrm>
           <a:prstGeom prst="rect">
             <a:avLst/>
@@ -6057,26 +4326,26 @@
           <a:p>
             <a:pPr algn="l"/>
             <a:r>
-              <a:rPr sz="1700" b="0">
+              <a:rPr sz="1500" b="0">
                 <a:solidFill>
                   <a:srgbClr val="FFFFFF"/>
                 </a:solidFill>
               </a:rPr>
-              <a:t>• Where does session state live?</a:t>
-            </a:r>
-          </a:p>
-        </p:txBody>
-      </p:sp>
-      <p:sp>
-        <p:nvSpPr>
-          <p:cNvPr id="8" name="TextBox 7"/>
+              <a:t>▸  Cloudflare: this.setState() on a Durable Object — atomic, co-located with compute, but proprietary</a:t>
+            </a:r>
+          </a:p>
+        </p:txBody>
+      </p:sp>
+      <p:sp>
+        <p:nvSpPr>
+          <p:cNvPr id="9" name="TextBox 8"/>
           <p:cNvSpPr txBox="1"/>
           <p:nvPr/>
         </p:nvSpPr>
         <p:spPr>
           <a:xfrm>
-            <a:off x="777240" y="5230368"/>
-            <a:ext cx="10607040" cy="822960"/>
+            <a:off x="502920" y="3767328"/>
+            <a:ext cx="11155680" cy="731520"/>
           </a:xfrm>
           <a:prstGeom prst="rect">
             <a:avLst/>
@@ -6091,26 +4360,26 @@
           <a:p>
             <a:pPr algn="l"/>
             <a:r>
-              <a:rPr sz="1700" b="0">
+              <a:rPr sz="1500" b="0">
                 <a:solidFill>
                   <a:srgbClr val="FFFFFF"/>
                 </a:solidFill>
               </a:rPr>
-              <a:t>• How would you implement long-term memory of the user's monthly spending patterns?</a:t>
-            </a:r>
-          </a:p>
-        </p:txBody>
-      </p:sp>
-      <p:sp>
-        <p:nvSpPr>
-          <p:cNvPr id="9" name="TextBox 8"/>
+              <a:t>▸  GEAP wins on convenience; Claude SDK wins on portability; Cloudflare wins on co-located simplicity</a:t>
+            </a:r>
+          </a:p>
+        </p:txBody>
+      </p:sp>
+      <p:sp>
+        <p:nvSpPr>
+          <p:cNvPr id="10" name="TextBox 9"/>
           <p:cNvSpPr txBox="1"/>
           <p:nvPr/>
         </p:nvSpPr>
         <p:spPr>
           <a:xfrm>
-            <a:off x="731520" y="6263640"/>
-            <a:ext cx="10698480" cy="320040"/>
+            <a:off x="502920" y="4590288"/>
+            <a:ext cx="11155680" cy="731520"/>
           </a:xfrm>
           <a:prstGeom prst="rect">
             <a:avLst/>
@@ -6125,9 +4394,985 @@
           <a:p>
             <a:pPr algn="l"/>
             <a:r>
+              <a:rPr sz="1500" b="0">
+                <a:solidFill>
+                  <a:srgbClr val="FFFFFF"/>
+                </a:solidFill>
+              </a:rPr>
+              <a:t>▸  Memory Bank has no export API at launch — factor migration cost in before adopting GEAP for state</a:t>
+            </a:r>
+          </a:p>
+        </p:txBody>
+      </p:sp>
+      <p:sp>
+        <p:nvSpPr>
+          <p:cNvPr id="11" name="TextBox 10"/>
+          <p:cNvSpPr txBox="1"/>
+          <p:nvPr/>
+        </p:nvSpPr>
+        <p:spPr>
+          <a:xfrm>
+            <a:off x="457200" y="6492240"/>
+            <a:ext cx="11247120" cy="320040"/>
+          </a:xfrm>
+          <a:prstGeom prst="rect">
+            <a:avLst/>
+          </a:prstGeom>
+          <a:noFill/>
+        </p:spPr>
+        <p:txBody>
+          <a:bodyPr wrap="square">
+            <a:spAutoFit/>
+          </a:bodyPr>
+          <a:lstStyle/>
+          <a:p>
+            <a:pPr algn="l"/>
+            <a:r>
               <a:rPr sz="1000" b="0">
                 <a:solidFill>
                   <a:srgbClr val="A1A1AA"/>
+                </a:solidFill>
+              </a:rPr>
+              <a:t>academy.kspl.tech | Koenig AI Academy</a:t>
+            </a:r>
+          </a:p>
+        </p:txBody>
+      </p:sp>
+    </p:spTree>
+  </p:cSld>
+  <p:clrMapOvr>
+    <a:masterClrMapping/>
+  </p:clrMapOvr>
+</p:sld>
+</file>
+
+<file path=ppt/slides/slide5.xml><?xml version="1.0" encoding="utf-8"?>
+<p:sld xmlns:a="http://schemas.openxmlformats.org/drawingml/2006/main" xmlns:p="http://schemas.openxmlformats.org/presentationml/2006/main" xmlns:r="http://schemas.openxmlformats.org/officeDocument/2006/relationships">
+  <p:cSld>
+    <p:spTree>
+      <p:nvGrpSpPr>
+        <p:cNvPr id="1" name=""/>
+        <p:cNvGrpSpPr/>
+        <p:nvPr/>
+      </p:nvGrpSpPr>
+      <p:grpSpPr/>
+      <p:sp>
+        <p:nvSpPr>
+          <p:cNvPr id="2" name="Rectangle 1"/>
+          <p:cNvSpPr/>
+          <p:nvPr/>
+        </p:nvSpPr>
+        <p:spPr>
+          <a:xfrm>
+            <a:off x="0" y="0"/>
+            <a:ext cx="12191695" cy="6858000"/>
+          </a:xfrm>
+          <a:prstGeom prst="rect">
+            <a:avLst/>
+          </a:prstGeom>
+          <a:solidFill>
+            <a:srgbClr val="18181B"/>
+          </a:solidFill>
+          <a:ln>
+            <a:noFill/>
+          </a:ln>
+        </p:spPr>
+        <p:style>
+          <a:lnRef idx="1">
+            <a:schemeClr val="accent1"/>
+          </a:lnRef>
+          <a:fillRef idx="3">
+            <a:schemeClr val="accent1"/>
+          </a:fillRef>
+          <a:effectRef idx="2">
+            <a:schemeClr val="accent1"/>
+          </a:effectRef>
+          <a:fontRef idx="minor">
+            <a:schemeClr val="lt1"/>
+          </a:fontRef>
+        </p:style>
+        <p:txBody>
+          <a:bodyPr rtlCol="0" anchor="ctr"/>
+          <a:lstStyle/>
+          <a:p>
+            <a:pPr algn="ctr"/>
+          </a:p>
+        </p:txBody>
+      </p:sp>
+      <p:sp>
+        <p:nvSpPr>
+          <p:cNvPr id="3" name="Rectangle 2"/>
+          <p:cNvSpPr/>
+          <p:nvPr/>
+        </p:nvSpPr>
+        <p:spPr>
+          <a:xfrm>
+            <a:off x="0" y="0"/>
+            <a:ext cx="12191695" cy="54864"/>
+          </a:xfrm>
+          <a:prstGeom prst="rect">
+            <a:avLst/>
+          </a:prstGeom>
+          <a:solidFill>
+            <a:srgbClr val="6366F1"/>
+          </a:solidFill>
+          <a:ln>
+            <a:noFill/>
+          </a:ln>
+        </p:spPr>
+        <p:style>
+          <a:lnRef idx="1">
+            <a:schemeClr val="accent1"/>
+          </a:lnRef>
+          <a:fillRef idx="3">
+            <a:schemeClr val="accent1"/>
+          </a:fillRef>
+          <a:effectRef idx="2">
+            <a:schemeClr val="accent1"/>
+          </a:effectRef>
+          <a:fontRef idx="minor">
+            <a:schemeClr val="lt1"/>
+          </a:fontRef>
+        </p:style>
+        <p:txBody>
+          <a:bodyPr rtlCol="0" anchor="ctr"/>
+          <a:lstStyle/>
+          <a:p>
+            <a:pPr algn="ctr"/>
+          </a:p>
+        </p:txBody>
+      </p:sp>
+      <p:sp>
+        <p:nvSpPr>
+          <p:cNvPr id="4" name="TextBox 3"/>
+          <p:cNvSpPr txBox="1"/>
+          <p:nvPr/>
+        </p:nvSpPr>
+        <p:spPr>
+          <a:xfrm>
+            <a:off x="457200" y="164592"/>
+            <a:ext cx="11247120" cy="868680"/>
+          </a:xfrm>
+          <a:prstGeom prst="rect">
+            <a:avLst/>
+          </a:prstGeom>
+          <a:noFill/>
+        </p:spPr>
+        <p:txBody>
+          <a:bodyPr wrap="square">
+            <a:spAutoFit/>
+          </a:bodyPr>
+          <a:lstStyle/>
+          <a:p>
+            <a:pPr algn="l"/>
+            <a:r>
+              <a:rPr sz="2800" b="1">
+                <a:solidFill>
+                  <a:srgbClr val="FFFFFF"/>
+                </a:solidFill>
+              </a:rPr>
+              <a:t>Deployment Topology</a:t>
+            </a:r>
+          </a:p>
+        </p:txBody>
+      </p:sp>
+      <p:sp>
+        <p:nvSpPr>
+          <p:cNvPr id="5" name="Rectangle 4"/>
+          <p:cNvSpPr/>
+          <p:nvPr/>
+        </p:nvSpPr>
+        <p:spPr>
+          <a:xfrm>
+            <a:off x="457200" y="1143000"/>
+            <a:ext cx="11247120" cy="27432"/>
+          </a:xfrm>
+          <a:prstGeom prst="rect">
+            <a:avLst/>
+          </a:prstGeom>
+          <a:solidFill>
+            <a:srgbClr val="A1A1AA"/>
+          </a:solidFill>
+          <a:ln>
+            <a:noFill/>
+          </a:ln>
+        </p:spPr>
+        <p:style>
+          <a:lnRef idx="1">
+            <a:schemeClr val="accent1"/>
+          </a:lnRef>
+          <a:fillRef idx="3">
+            <a:schemeClr val="accent1"/>
+          </a:fillRef>
+          <a:effectRef idx="2">
+            <a:schemeClr val="accent1"/>
+          </a:effectRef>
+          <a:fontRef idx="minor">
+            <a:schemeClr val="lt1"/>
+          </a:fontRef>
+        </p:style>
+        <p:txBody>
+          <a:bodyPr rtlCol="0" anchor="ctr"/>
+          <a:lstStyle/>
+          <a:p>
+            <a:pPr algn="ctr"/>
+          </a:p>
+        </p:txBody>
+      </p:sp>
+      <p:sp>
+        <p:nvSpPr>
+          <p:cNvPr id="6" name="TextBox 5"/>
+          <p:cNvSpPr txBox="1"/>
+          <p:nvPr/>
+        </p:nvSpPr>
+        <p:spPr>
+          <a:xfrm>
+            <a:off x="502920" y="1298448"/>
+            <a:ext cx="11155680" cy="731520"/>
+          </a:xfrm>
+          <a:prstGeom prst="rect">
+            <a:avLst/>
+          </a:prstGeom>
+          <a:noFill/>
+        </p:spPr>
+        <p:txBody>
+          <a:bodyPr wrap="square">
+            <a:spAutoFit/>
+          </a:bodyPr>
+          <a:lstStyle/>
+          <a:p>
+            <a:pPr algn="l"/>
+            <a:r>
+              <a:rPr sz="1500" b="0">
+                <a:solidFill>
+                  <a:srgbClr val="FFFFFF"/>
+                </a:solidFill>
+              </a:rPr>
+              <a:t>▸  GEAP: GCP regional (us-central1, europe-west4) — compliance features, GCP ecosystem integration</a:t>
+            </a:r>
+          </a:p>
+        </p:txBody>
+      </p:sp>
+      <p:sp>
+        <p:nvSpPr>
+          <p:cNvPr id="7" name="TextBox 6"/>
+          <p:cNvSpPr txBox="1"/>
+          <p:nvPr/>
+        </p:nvSpPr>
+        <p:spPr>
+          <a:xfrm>
+            <a:off x="502920" y="2121408"/>
+            <a:ext cx="11155680" cy="731520"/>
+          </a:xfrm>
+          <a:prstGeom prst="rect">
+            <a:avLst/>
+          </a:prstGeom>
+          <a:noFill/>
+        </p:spPr>
+        <p:txBody>
+          <a:bodyPr wrap="square">
+            <a:spAutoFit/>
+          </a:bodyPr>
+          <a:lstStyle/>
+          <a:p>
+            <a:pPr algn="l"/>
+            <a:r>
+              <a:rPr sz="1500" b="0">
+                <a:solidFill>
+                  <a:srgbClr val="FFFFFF"/>
+                </a:solidFill>
+              </a:rPr>
+              <a:t>▸  Claude SDK: deploy on any infra — any cloud, on-premises, or hybrid; no platform lock</a:t>
+            </a:r>
+          </a:p>
+        </p:txBody>
+      </p:sp>
+      <p:sp>
+        <p:nvSpPr>
+          <p:cNvPr id="8" name="TextBox 7"/>
+          <p:cNvSpPr txBox="1"/>
+          <p:nvPr/>
+        </p:nvSpPr>
+        <p:spPr>
+          <a:xfrm>
+            <a:off x="502920" y="2944368"/>
+            <a:ext cx="11155680" cy="731520"/>
+          </a:xfrm>
+          <a:prstGeom prst="rect">
+            <a:avLst/>
+          </a:prstGeom>
+          <a:noFill/>
+        </p:spPr>
+        <p:txBody>
+          <a:bodyPr wrap="square">
+            <a:spAutoFit/>
+          </a:bodyPr>
+          <a:lstStyle/>
+          <a:p>
+            <a:pPr algn="l"/>
+            <a:r>
+              <a:rPr sz="1500" b="0">
+                <a:solidFill>
+                  <a:srgbClr val="FFFFFF"/>
+                </a:solidFill>
+              </a:rPr>
+              <a:t>▸  Cloudflare: 300+ global edge PoPs, sub-millisecond cold starts, WebSocket native via Durable Objects</a:t>
+            </a:r>
+          </a:p>
+        </p:txBody>
+      </p:sp>
+      <p:sp>
+        <p:nvSpPr>
+          <p:cNvPr id="9" name="TextBox 8"/>
+          <p:cNvSpPr txBox="1"/>
+          <p:nvPr/>
+        </p:nvSpPr>
+        <p:spPr>
+          <a:xfrm>
+            <a:off x="502920" y="3767328"/>
+            <a:ext cx="11155680" cy="731520"/>
+          </a:xfrm>
+          <a:prstGeom prst="rect">
+            <a:avLst/>
+          </a:prstGeom>
+          <a:noFill/>
+        </p:spPr>
+        <p:txBody>
+          <a:bodyPr wrap="square">
+            <a:spAutoFit/>
+          </a:bodyPr>
+          <a:lstStyle/>
+          <a:p>
+            <a:pPr algn="l"/>
+            <a:r>
+              <a:rPr sz="1500" b="0">
+                <a:solidFill>
+                  <a:srgbClr val="FFFFFF"/>
+                </a:solidFill>
+              </a:rPr>
+              <a:t>▸  Real-time workloads: Cloudflare wins on latency; regulated workloads: GEAP wins on governance</a:t>
+            </a:r>
+          </a:p>
+        </p:txBody>
+      </p:sp>
+      <p:sp>
+        <p:nvSpPr>
+          <p:cNvPr id="10" name="TextBox 9"/>
+          <p:cNvSpPr txBox="1"/>
+          <p:nvPr/>
+        </p:nvSpPr>
+        <p:spPr>
+          <a:xfrm>
+            <a:off x="502920" y="4590288"/>
+            <a:ext cx="11155680" cy="731520"/>
+          </a:xfrm>
+          <a:prstGeom prst="rect">
+            <a:avLst/>
+          </a:prstGeom>
+          <a:noFill/>
+        </p:spPr>
+        <p:txBody>
+          <a:bodyPr wrap="square">
+            <a:spAutoFit/>
+          </a:bodyPr>
+          <a:lstStyle/>
+          <a:p>
+            <a:pPr algn="l"/>
+            <a:r>
+              <a:rPr sz="1500" b="0">
+                <a:solidFill>
+                  <a:srgbClr val="FFFFFF"/>
+                </a:solidFill>
+              </a:rPr>
+              <a:t>▸  Scheduling: GEAP via Cloud Scheduler, Cloudflare via Durable Object alarms, Claude SDK: bring your own</a:t>
+            </a:r>
+          </a:p>
+        </p:txBody>
+      </p:sp>
+      <p:sp>
+        <p:nvSpPr>
+          <p:cNvPr id="11" name="TextBox 10"/>
+          <p:cNvSpPr txBox="1"/>
+          <p:nvPr/>
+        </p:nvSpPr>
+        <p:spPr>
+          <a:xfrm>
+            <a:off x="457200" y="6492240"/>
+            <a:ext cx="11247120" cy="320040"/>
+          </a:xfrm>
+          <a:prstGeom prst="rect">
+            <a:avLst/>
+          </a:prstGeom>
+          <a:noFill/>
+        </p:spPr>
+        <p:txBody>
+          <a:bodyPr wrap="square">
+            <a:spAutoFit/>
+          </a:bodyPr>
+          <a:lstStyle/>
+          <a:p>
+            <a:pPr algn="l"/>
+            <a:r>
+              <a:rPr sz="1000" b="0">
+                <a:solidFill>
+                  <a:srgbClr val="A1A1AA"/>
+                </a:solidFill>
+              </a:rPr>
+              <a:t>academy.kspl.tech | Koenig AI Academy</a:t>
+            </a:r>
+          </a:p>
+        </p:txBody>
+      </p:sp>
+    </p:spTree>
+  </p:cSld>
+  <p:clrMapOvr>
+    <a:masterClrMapping/>
+  </p:clrMapOvr>
+</p:sld>
+</file>
+
+<file path=ppt/slides/slide6.xml><?xml version="1.0" encoding="utf-8"?>
+<p:sld xmlns:a="http://schemas.openxmlformats.org/drawingml/2006/main" xmlns:p="http://schemas.openxmlformats.org/presentationml/2006/main" xmlns:r="http://schemas.openxmlformats.org/officeDocument/2006/relationships">
+  <p:cSld>
+    <p:spTree>
+      <p:nvGrpSpPr>
+        <p:cNvPr id="1" name=""/>
+        <p:cNvGrpSpPr/>
+        <p:nvPr/>
+      </p:nvGrpSpPr>
+      <p:grpSpPr/>
+      <p:sp>
+        <p:nvSpPr>
+          <p:cNvPr id="2" name="Rectangle 1"/>
+          <p:cNvSpPr/>
+          <p:nvPr/>
+        </p:nvSpPr>
+        <p:spPr>
+          <a:xfrm>
+            <a:off x="0" y="0"/>
+            <a:ext cx="12191695" cy="6858000"/>
+          </a:xfrm>
+          <a:prstGeom prst="rect">
+            <a:avLst/>
+          </a:prstGeom>
+          <a:solidFill>
+            <a:srgbClr val="18181B"/>
+          </a:solidFill>
+          <a:ln>
+            <a:noFill/>
+          </a:ln>
+        </p:spPr>
+        <p:style>
+          <a:lnRef idx="1">
+            <a:schemeClr val="accent1"/>
+          </a:lnRef>
+          <a:fillRef idx="3">
+            <a:schemeClr val="accent1"/>
+          </a:fillRef>
+          <a:effectRef idx="2">
+            <a:schemeClr val="accent1"/>
+          </a:effectRef>
+          <a:fontRef idx="minor">
+            <a:schemeClr val="lt1"/>
+          </a:fontRef>
+        </p:style>
+        <p:txBody>
+          <a:bodyPr rtlCol="0" anchor="ctr"/>
+          <a:lstStyle/>
+          <a:p>
+            <a:pPr algn="ctr"/>
+          </a:p>
+        </p:txBody>
+      </p:sp>
+      <p:sp>
+        <p:nvSpPr>
+          <p:cNvPr id="3" name="Rectangle 2"/>
+          <p:cNvSpPr/>
+          <p:nvPr/>
+        </p:nvSpPr>
+        <p:spPr>
+          <a:xfrm>
+            <a:off x="0" y="0"/>
+            <a:ext cx="12191695" cy="54864"/>
+          </a:xfrm>
+          <a:prstGeom prst="rect">
+            <a:avLst/>
+          </a:prstGeom>
+          <a:solidFill>
+            <a:srgbClr val="6366F1"/>
+          </a:solidFill>
+          <a:ln>
+            <a:noFill/>
+          </a:ln>
+        </p:spPr>
+        <p:style>
+          <a:lnRef idx="1">
+            <a:schemeClr val="accent1"/>
+          </a:lnRef>
+          <a:fillRef idx="3">
+            <a:schemeClr val="accent1"/>
+          </a:fillRef>
+          <a:effectRef idx="2">
+            <a:schemeClr val="accent1"/>
+          </a:effectRef>
+          <a:fontRef idx="minor">
+            <a:schemeClr val="lt1"/>
+          </a:fontRef>
+        </p:style>
+        <p:txBody>
+          <a:bodyPr rtlCol="0" anchor="ctr"/>
+          <a:lstStyle/>
+          <a:p>
+            <a:pPr algn="ctr"/>
+          </a:p>
+        </p:txBody>
+      </p:sp>
+      <p:sp>
+        <p:nvSpPr>
+          <p:cNvPr id="4" name="TextBox 3"/>
+          <p:cNvSpPr txBox="1"/>
+          <p:nvPr/>
+        </p:nvSpPr>
+        <p:spPr>
+          <a:xfrm>
+            <a:off x="457200" y="164592"/>
+            <a:ext cx="11247120" cy="868680"/>
+          </a:xfrm>
+          <a:prstGeom prst="rect">
+            <a:avLst/>
+          </a:prstGeom>
+          <a:noFill/>
+        </p:spPr>
+        <p:txBody>
+          <a:bodyPr wrap="square">
+            <a:spAutoFit/>
+          </a:bodyPr>
+          <a:lstStyle/>
+          <a:p>
+            <a:pPr algn="l"/>
+            <a:r>
+              <a:rPr sz="2800" b="1">
+                <a:solidFill>
+                  <a:srgbClr val="FFFFFF"/>
+                </a:solidFill>
+              </a:rPr>
+              <a:t>Decision Framework — Which Platform When</a:t>
+            </a:r>
+          </a:p>
+        </p:txBody>
+      </p:sp>
+      <p:sp>
+        <p:nvSpPr>
+          <p:cNvPr id="5" name="Rectangle 4"/>
+          <p:cNvSpPr/>
+          <p:nvPr/>
+        </p:nvSpPr>
+        <p:spPr>
+          <a:xfrm>
+            <a:off x="457200" y="1143000"/>
+            <a:ext cx="11247120" cy="27432"/>
+          </a:xfrm>
+          <a:prstGeom prst="rect">
+            <a:avLst/>
+          </a:prstGeom>
+          <a:solidFill>
+            <a:srgbClr val="A1A1AA"/>
+          </a:solidFill>
+          <a:ln>
+            <a:noFill/>
+          </a:ln>
+        </p:spPr>
+        <p:style>
+          <a:lnRef idx="1">
+            <a:schemeClr val="accent1"/>
+          </a:lnRef>
+          <a:fillRef idx="3">
+            <a:schemeClr val="accent1"/>
+          </a:fillRef>
+          <a:effectRef idx="2">
+            <a:schemeClr val="accent1"/>
+          </a:effectRef>
+          <a:fontRef idx="minor">
+            <a:schemeClr val="lt1"/>
+          </a:fontRef>
+        </p:style>
+        <p:txBody>
+          <a:bodyPr rtlCol="0" anchor="ctr"/>
+          <a:lstStyle/>
+          <a:p>
+            <a:pPr algn="ctr"/>
+          </a:p>
+        </p:txBody>
+      </p:sp>
+      <p:sp>
+        <p:nvSpPr>
+          <p:cNvPr id="6" name="TextBox 5"/>
+          <p:cNvSpPr txBox="1"/>
+          <p:nvPr/>
+        </p:nvSpPr>
+        <p:spPr>
+          <a:xfrm>
+            <a:off x="502920" y="1298448"/>
+            <a:ext cx="11155680" cy="868680"/>
+          </a:xfrm>
+          <a:prstGeom prst="rect">
+            <a:avLst/>
+          </a:prstGeom>
+          <a:noFill/>
+        </p:spPr>
+        <p:txBody>
+          <a:bodyPr wrap="square">
+            <a:spAutoFit/>
+          </a:bodyPr>
+          <a:lstStyle/>
+          <a:p>
+            <a:pPr algn="l"/>
+            <a:r>
+              <a:rPr sz="1700" b="0">
+                <a:solidFill>
+                  <a:srgbClr val="FFFFFF"/>
+                </a:solidFill>
+              </a:rPr>
+              <a:t>▸  Choose GEAP when on GCP, needing enterprise governance, or orchestrating five or more agents</a:t>
+            </a:r>
+          </a:p>
+        </p:txBody>
+      </p:sp>
+      <p:sp>
+        <p:nvSpPr>
+          <p:cNvPr id="7" name="TextBox 6"/>
+          <p:cNvSpPr txBox="1"/>
+          <p:nvPr/>
+        </p:nvSpPr>
+        <p:spPr>
+          <a:xfrm>
+            <a:off x="502920" y="2258568"/>
+            <a:ext cx="11155680" cy="868680"/>
+          </a:xfrm>
+          <a:prstGeom prst="rect">
+            <a:avLst/>
+          </a:prstGeom>
+          <a:noFill/>
+        </p:spPr>
+        <p:txBody>
+          <a:bodyPr wrap="square">
+            <a:spAutoFit/>
+          </a:bodyPr>
+          <a:lstStyle/>
+          <a:p>
+            <a:pPr algn="l"/>
+            <a:r>
+              <a:rPr sz="1700" b="0">
+                <a:solidFill>
+                  <a:srgbClr val="FFFFFF"/>
+                </a:solidFill>
+              </a:rPr>
+              <a:t>▸  Choose Claude SDK when reasoning quality is the priority or vendor lock-in must be minimised</a:t>
+            </a:r>
+          </a:p>
+        </p:txBody>
+      </p:sp>
+      <p:sp>
+        <p:nvSpPr>
+          <p:cNvPr id="8" name="TextBox 7"/>
+          <p:cNvSpPr txBox="1"/>
+          <p:nvPr/>
+        </p:nvSpPr>
+        <p:spPr>
+          <a:xfrm>
+            <a:off x="502920" y="3218688"/>
+            <a:ext cx="11155680" cy="868680"/>
+          </a:xfrm>
+          <a:prstGeom prst="rect">
+            <a:avLst/>
+          </a:prstGeom>
+          <a:noFill/>
+        </p:spPr>
+        <p:txBody>
+          <a:bodyPr wrap="square">
+            <a:spAutoFit/>
+          </a:bodyPr>
+          <a:lstStyle/>
+          <a:p>
+            <a:pPr algn="l"/>
+            <a:r>
+              <a:rPr sz="1700" b="0">
+                <a:solidFill>
+                  <a:srgbClr val="FFFFFF"/>
+                </a:solidFill>
+              </a:rPr>
+              <a:t>▸  Choose Cloudflare Agents when latency is critical, the team is TypeScript-native, or state is simple</a:t>
+            </a:r>
+          </a:p>
+        </p:txBody>
+      </p:sp>
+      <p:sp>
+        <p:nvSpPr>
+          <p:cNvPr id="9" name="TextBox 8"/>
+          <p:cNvSpPr txBox="1"/>
+          <p:nvPr/>
+        </p:nvSpPr>
+        <p:spPr>
+          <a:xfrm>
+            <a:off x="502920" y="4178808"/>
+            <a:ext cx="11155680" cy="868680"/>
+          </a:xfrm>
+          <a:prstGeom prst="rect">
+            <a:avLst/>
+          </a:prstGeom>
+          <a:noFill/>
+        </p:spPr>
+        <p:txBody>
+          <a:bodyPr wrap="square">
+            <a:spAutoFit/>
+          </a:bodyPr>
+          <a:lstStyle/>
+          <a:p>
+            <a:pPr algn="l"/>
+            <a:r>
+              <a:rPr sz="1700" b="0">
+                <a:solidFill>
+                  <a:srgbClr val="FFFFFF"/>
+                </a:solidFill>
+              </a:rPr>
+              <a:t>▸  Hybrid patterns work: GEAP orchestration + Claude Opus sub-agents; Cloudflare edge + GEAP backend</a:t>
+            </a:r>
+          </a:p>
+        </p:txBody>
+      </p:sp>
+      <p:sp>
+        <p:nvSpPr>
+          <p:cNvPr id="10" name="TextBox 9"/>
+          <p:cNvSpPr txBox="1"/>
+          <p:nvPr/>
+        </p:nvSpPr>
+        <p:spPr>
+          <a:xfrm>
+            <a:off x="457200" y="6492240"/>
+            <a:ext cx="11247120" cy="320040"/>
+          </a:xfrm>
+          <a:prstGeom prst="rect">
+            <a:avLst/>
+          </a:prstGeom>
+          <a:noFill/>
+        </p:spPr>
+        <p:txBody>
+          <a:bodyPr wrap="square">
+            <a:spAutoFit/>
+          </a:bodyPr>
+          <a:lstStyle/>
+          <a:p>
+            <a:pPr algn="l"/>
+            <a:r>
+              <a:rPr sz="1000" b="0">
+                <a:solidFill>
+                  <a:srgbClr val="A1A1AA"/>
+                </a:solidFill>
+              </a:rPr>
+              <a:t>academy.kspl.tech | Koenig AI Academy</a:t>
+            </a:r>
+          </a:p>
+        </p:txBody>
+      </p:sp>
+    </p:spTree>
+  </p:cSld>
+  <p:clrMapOvr>
+    <a:masterClrMapping/>
+  </p:clrMapOvr>
+</p:sld>
+</file>
+
+<file path=ppt/slides/slide7.xml><?xml version="1.0" encoding="utf-8"?>
+<p:sld xmlns:a="http://schemas.openxmlformats.org/drawingml/2006/main" xmlns:p="http://schemas.openxmlformats.org/presentationml/2006/main" xmlns:r="http://schemas.openxmlformats.org/officeDocument/2006/relationships">
+  <p:cSld>
+    <p:spTree>
+      <p:nvGrpSpPr>
+        <p:cNvPr id="1" name=""/>
+        <p:cNvGrpSpPr/>
+        <p:nvPr/>
+      </p:nvGrpSpPr>
+      <p:grpSpPr/>
+      <p:sp>
+        <p:nvSpPr>
+          <p:cNvPr id="2" name="Rectangle 1"/>
+          <p:cNvSpPr/>
+          <p:nvPr/>
+        </p:nvSpPr>
+        <p:spPr>
+          <a:xfrm>
+            <a:off x="0" y="0"/>
+            <a:ext cx="12191695" cy="6858000"/>
+          </a:xfrm>
+          <a:prstGeom prst="rect">
+            <a:avLst/>
+          </a:prstGeom>
+          <a:solidFill>
+            <a:srgbClr val="18181B"/>
+          </a:solidFill>
+          <a:ln>
+            <a:noFill/>
+          </a:ln>
+        </p:spPr>
+        <p:style>
+          <a:lnRef idx="1">
+            <a:schemeClr val="accent1"/>
+          </a:lnRef>
+          <a:fillRef idx="3">
+            <a:schemeClr val="accent1"/>
+          </a:fillRef>
+          <a:effectRef idx="2">
+            <a:schemeClr val="accent1"/>
+          </a:effectRef>
+          <a:fontRef idx="minor">
+            <a:schemeClr val="lt1"/>
+          </a:fontRef>
+        </p:style>
+        <p:txBody>
+          <a:bodyPr rtlCol="0" anchor="ctr"/>
+          <a:lstStyle/>
+          <a:p>
+            <a:pPr algn="ctr"/>
+          </a:p>
+        </p:txBody>
+      </p:sp>
+      <p:sp>
+        <p:nvSpPr>
+          <p:cNvPr id="3" name="Rectangle 2"/>
+          <p:cNvSpPr/>
+          <p:nvPr/>
+        </p:nvSpPr>
+        <p:spPr>
+          <a:xfrm>
+            <a:off x="0" y="0"/>
+            <a:ext cx="54864" cy="6858000"/>
+          </a:xfrm>
+          <a:prstGeom prst="rect">
+            <a:avLst/>
+          </a:prstGeom>
+          <a:solidFill>
+            <a:srgbClr val="6366F1"/>
+          </a:solidFill>
+          <a:ln>
+            <a:noFill/>
+          </a:ln>
+        </p:spPr>
+        <p:style>
+          <a:lnRef idx="1">
+            <a:schemeClr val="accent1"/>
+          </a:lnRef>
+          <a:fillRef idx="3">
+            <a:schemeClr val="accent1"/>
+          </a:fillRef>
+          <a:effectRef idx="2">
+            <a:schemeClr val="accent1"/>
+          </a:effectRef>
+          <a:fontRef idx="minor">
+            <a:schemeClr val="lt1"/>
+          </a:fontRef>
+        </p:style>
+        <p:txBody>
+          <a:bodyPr rtlCol="0" anchor="ctr"/>
+          <a:lstStyle/>
+          <a:p>
+            <a:pPr algn="ctr"/>
+          </a:p>
+        </p:txBody>
+      </p:sp>
+      <p:sp>
+        <p:nvSpPr>
+          <p:cNvPr id="4" name="TextBox 3"/>
+          <p:cNvSpPr txBox="1"/>
+          <p:nvPr/>
+        </p:nvSpPr>
+        <p:spPr>
+          <a:xfrm>
+            <a:off x="914400" y="1828800"/>
+            <a:ext cx="10332720" cy="731520"/>
+          </a:xfrm>
+          <a:prstGeom prst="rect">
+            <a:avLst/>
+          </a:prstGeom>
+          <a:noFill/>
+        </p:spPr>
+        <p:txBody>
+          <a:bodyPr wrap="square">
+            <a:spAutoFit/>
+          </a:bodyPr>
+          <a:lstStyle/>
+          <a:p>
+            <a:pPr algn="ctr"/>
+            <a:r>
+              <a:rPr sz="3600" b="1">
+                <a:solidFill>
+                  <a:srgbClr val="FFFFFF"/>
+                </a:solidFill>
+              </a:rPr>
+              <a:t>Try It Next</a:t>
+            </a:r>
+          </a:p>
+        </p:txBody>
+      </p:sp>
+      <p:sp>
+        <p:nvSpPr>
+          <p:cNvPr id="5" name="TextBox 4"/>
+          <p:cNvSpPr txBox="1"/>
+          <p:nvPr/>
+        </p:nvSpPr>
+        <p:spPr>
+          <a:xfrm>
+            <a:off x="914400" y="2743200"/>
+            <a:ext cx="10332720" cy="640080"/>
+          </a:xfrm>
+          <a:prstGeom prst="rect">
+            <a:avLst/>
+          </a:prstGeom>
+          <a:noFill/>
+        </p:spPr>
+        <p:txBody>
+          <a:bodyPr wrap="square">
+            <a:spAutoFit/>
+          </a:bodyPr>
+          <a:lstStyle/>
+          <a:p>
+            <a:pPr algn="ctr"/>
+            <a:r>
+              <a:rPr sz="2200" b="0">
+                <a:solidFill>
+                  <a:srgbClr val="A1A1AA"/>
+                </a:solidFill>
+              </a:rPr>
+              <a:t>Capstone: Build a Two-Agent Invoice-Processing Pipeline</a:t>
+            </a:r>
+          </a:p>
+        </p:txBody>
+      </p:sp>
+      <p:sp>
+        <p:nvSpPr>
+          <p:cNvPr id="6" name="TextBox 5"/>
+          <p:cNvSpPr txBox="1"/>
+          <p:nvPr/>
+        </p:nvSpPr>
+        <p:spPr>
+          <a:xfrm>
+            <a:off x="914400" y="3840480"/>
+            <a:ext cx="10332720" cy="457200"/>
+          </a:xfrm>
+          <a:prstGeom prst="rect">
+            <a:avLst/>
+          </a:prstGeom>
+          <a:noFill/>
+        </p:spPr>
+        <p:txBody>
+          <a:bodyPr wrap="square">
+            <a:spAutoFit/>
+          </a:bodyPr>
+          <a:lstStyle/>
+          <a:p>
+            <a:pPr algn="ctr"/>
+            <a:r>
+              <a:rPr sz="1600" b="0">
+                <a:solidFill>
+                  <a:srgbClr val="6366F1"/>
                 </a:solidFill>
               </a:rPr>
               <a:t>academy.kspl.tech | Koenig AI Academy</a:t>

</xml_diff>